<commit_message>
Per-segment bias calibration of the LightGBM forecast (fixes D13, D14 at 1x); refresh 1x results, screenshots, deck and docs
- calibration_factors: actual/forecast per ABC x pattern segment from earlier backtest folds only,
  shrunk toward 1 (1,000 pseudo-units) and capped at +/-25%; applied to later folds and the final forecast
- held-out bias -0.8% -> 0.0%, A-class lumpy -7.2% -> -0.2%, WAPE unchanged (49.8%)
- slide 7 crops are generated by presentation/make_charts.py from the dashboard screenshot
- 10x re-run and v1.0.1 release follow
</commit_message>
<xml_diff>
--- a/presentation/Stockflow_Stryker.pptx
+++ b/presentation/Stockflow_Stryker.pptx
@@ -605,7 +605,7 @@
           <a:lstStyle/>
           <a:p>
             <a:r>
-              <a:t>Here's the problem in one picture. Across the network there's $13.4M of inventory on hand. $8.3M of it, 62%, sits above the level each branch actually needs. At the same time, 411 branch-and-product combinations are likely to run out before their next replenishment arrives.</a:t>
+              <a:t>Here's the problem in one picture. Across the network there's $13.4M of inventory on hand. $8.3M of it, 62%, sits above the level each branch actually needs. At the same time, 419 branch-and-product combinations are likely to run out before their next replenishment arrives.</a:t>
             </a:r>
           </a:p>
           <a:p/>
@@ -617,7 +617,7 @@
           <a:p/>
           <a:p>
             <a:r>
-              <a:t>The chart shows where the money is. The gold bar is the inventory at the positions facing stock-outs: only $179k. The shortage isn't a lack of inventory; it's inventory in the wrong place. A branch in one city has months of supply while another is about to stock out of the same item.</a:t>
+              <a:t>The chart shows where the money is. The gold bar is the inventory at the positions facing stock-outs: only $186k. The shortage isn't a lack of inventory; it's inventory in the wrong place. A branch in one city has months of supply while another is about to stock out of the same item.</a:t>
             </a:r>
           </a:p>
           <a:p/>
@@ -817,13 +817,13 @@
           <a:p/>
           <a:p>
             <a:r>
-              <a:t>The table compares models on the held-out month. WAPE is total absolute error as a share of actual units. The seasonal-naive baseline, which just repeats last week, misses by 75%. The selected models miss by 50%, a 34% improvement, with bias under one percent. Over a full 28-day total, which is what drives safety stock, the error is 13%.</a:t>
+              <a:t>The table compares models on the held-out month. WAPE is total absolute error as a share of actual units. The seasonal-naive baseline, which just repeats last week, misses by 75%. The selected models miss by 50%, a 33% improvement, with bias under one percent. Over a full 28-day total, which is what drives safety stock, the error is 13%.</a:t>
             </a:r>
           </a:p>
           <a:p/>
           <a:p>
             <a:r>
-              <a:t>The P10-to-P90 band contained 84% of actual days against an 80% target: slightly conservative, which I've documented.</a:t>
+              <a:t>The P10-to-P90 band contained 83% of actual days against an 80% target: slightly conservative, which I've documented.</a:t>
             </a:r>
           </a:p>
           <a:p/>
@@ -905,25 +905,25 @@
           <a:p/>
           <a:p>
             <a:r>
-              <a:t>The map shows the 20 busiest corridors, out of 265; they carry 45% of the units. Black dots are branches sending stock, gold dots are branches receiving it.</a:t>
+              <a:t>The map shows the 20 busiest corridors, out of 259; they carry 45% of the units. Black dots are branches sending stock, gold dots are branches receiving it.</a:t>
             </a:r>
           </a:p>
           <a:p/>
           <a:p>
             <a:r>
-              <a:t>The table is the five most valuable moves. Every one is "excess to shortfall": a branch with more than it needs sending to a branch about to run out. For example, the top move sends 192 units of S0190 from B10 to B17 for $1k in freight and saves about $4k.</a:t>
+              <a:t>The table is the five most valuable moves. Every one is "excess to shortfall": a branch with more than it needs sending to a branch about to run out. For example, the top move sends 208 units of S0190 from B10 to B17 for $1k in freight and saves about $4k.</a:t>
             </a:r>
           </a:p>
           <a:p/>
           <a:p>
             <a:r>
-              <a:t>Overall: 883 transfers, $45k in freight, $203k net savings, compared with $193k from a simple rule of thumb that serves the most urgent shortages first.</a:t>
+              <a:t>Overall: 895 transfers, $46k in freight, $216k net savings, compared with $206k from a simple rule of thumb that serves the most urgent shortages first.</a:t>
             </a:r>
           </a:p>
           <a:p/>
           <a:p>
             <a:r>
-              <a:t>Likely question: "How stable is the plan?" Answer: I re-solved it with service level, freight cost, forecast error and forecast level each changed. 66% to 92% of the same moves survive, and net savings stay between $171k and $235k.</a:t>
+              <a:t>Likely question: "How stable is the plan?" Answer: I re-solved it with service level, freight cost, forecast error and forecast level each changed. 67% to 92% of the same moves survive, and net savings stay between $182k and $248k.</a:t>
             </a:r>
           </a:p>
         </p:txBody>
@@ -999,19 +999,19 @@
           <a:p/>
           <a:p>
             <a:r>
-              <a:t>The headline, in gold: $1.14M of excess inventory put back to work. Those units go where they'll sell instead of sitting on a shelf, which also means purchases the distribution center doesn't have to make.</a:t>
+              <a:t>The headline, in gold: $1.16M of excess inventory put back to work. Those units go where they'll sell instead of sitting on a shelf, which also means purchases the distribution center doesn't have to make.</a:t>
             </a:r>
           </a:p>
           <a:p/>
           <a:p>
             <a:r>
-              <a:t>For patients this is the line that matters most: expected lost-sale units during the replenishment lead time drop from 9,725 to 1,552. That's 84% of the units that would otherwise have been missing when someone asked for them. Positions at stock-out risk fall from 411 to 72.</a:t>
+              <a:t>For patients this is the line that matters most: expected lost-sale units during the replenishment lead time drop from 10,533 to 1,585. That's 85% of the units that would otherwise have been missing when someone asked for them. Positions at stock-out risk fall from 419 to 76.</a:t>
             </a:r>
           </a:p>
           <a:p/>
           <a:p>
             <a:r>
-              <a:t>The annual carrying cost of excess falls from $2.18M to $1.92M, and inventory turns improve from 8.4 to 8.9.</a:t>
+              <a:t>The annual carrying cost of excess falls from $2.18M to $1.90M, and inventory turns improve from 8.5 to 9.0.</a:t>
             </a:r>
           </a:p>
           <a:p/>
@@ -4726,7 +4726,7 @@
                 </a:solidFill>
                 <a:latin typeface="Arial"/>
               </a:rPr>
-              <a:t>62% of inventory dollars sit above target while 411 branch positions face stock-outs</a:t>
+              <a:t>62% of inventory dollars sit above target while 419 branch positions face stock-outs</a:t>
             </a:r>
           </a:p>
         </p:txBody>
@@ -6406,7 +6406,7 @@
                 </a:solidFill>
                 <a:latin typeface="Arial"/>
               </a:rPr>
-              <a:t>Forecasts are 34% more accurate than the seasonal baseline on a month the model never saw</a:t>
+              <a:t>Forecasts are 33% more accurate than the seasonal baseline on a month the model never saw</a:t>
             </a:r>
           </a:p>
         </p:txBody>
@@ -7265,7 +7265,7 @@
                           </a:solidFill>
                           <a:latin typeface="Arial"/>
                         </a:rPr>
-                        <a:t>49.7%</a:t>
+                        <a:t>49.8%</a:t>
                       </a:r>
                     </a:p>
                   </a:txBody>
@@ -7302,7 +7302,7 @@
                           </a:solidFill>
                           <a:latin typeface="Arial"/>
                         </a:rPr>
-                        <a:t>2.24</a:t>
+                        <a:t>2.25</a:t>
                       </a:r>
                     </a:p>
                   </a:txBody>
@@ -7339,7 +7339,7 @@
                           </a:solidFill>
                           <a:latin typeface="Arial"/>
                         </a:rPr>
-                        <a:t>-0.7%</a:t>
+                        <a:t>+0.0%</a:t>
                       </a:r>
                     </a:p>
                   </a:txBody>
@@ -7452,7 +7452,7 @@
                           </a:solidFill>
                           <a:latin typeface="Arial"/>
                         </a:rPr>
-                        <a:t>2.24</a:t>
+                        <a:t>2.25</a:t>
                       </a:r>
                     </a:p>
                   </a:txBody>
@@ -7489,7 +7489,7 @@
                           </a:solidFill>
                           <a:latin typeface="Arial"/>
                         </a:rPr>
-                        <a:t>-0.8%</a:t>
+                        <a:t>+0.0%</a:t>
                       </a:r>
                     </a:p>
                   </a:txBody>
@@ -7552,7 +7552,7 @@
                 </a:solidFill>
                 <a:latin typeface="Arial"/>
               </a:rPr>
-              <a:t>WAPE = absolute error ÷ actual units; MAE in units per day. P10–P90 band held 84% of actual days (target 80%).</a:t>
+              <a:t>WAPE = absolute error ÷ actual units; MAE in units per day. P10–P90 band held 83% of actual days (target 80%).</a:t>
             </a:r>
           </a:p>
         </p:txBody>
@@ -7639,7 +7639,7 @@
                 </a:solidFill>
                 <a:latin typeface="Arial"/>
               </a:rPr>
-              <a:t>883 transfers cost $45k to move and save $203k net, $10k more than a rule of thumb</a:t>
+              <a:t>895 transfers cost $46k to move and save $216k net, $11k more than a rule of thumb</a:t>
             </a:r>
           </a:p>
         </p:txBody>
@@ -7810,7 +7810,7 @@
                 </a:solidFill>
                 <a:latin typeface="Arial"/>
               </a:rPr>
-              <a:t>Top 20 of 265 corridors · line width = units · black = sending branch, gold = receiving</a:t>
+              <a:t>Top 20 of 259 corridors · line width = units · black = sending branch, gold = receiving</a:t>
             </a:r>
           </a:p>
         </p:txBody>
@@ -8125,7 +8125,7 @@
                           </a:solidFill>
                           <a:latin typeface="Arial"/>
                         </a:rPr>
-                        <a:t>192</a:t>
+                        <a:t>208</a:t>
                       </a:r>
                     </a:p>
                   </a:txBody>
@@ -8162,7 +8162,7 @@
                           </a:solidFill>
                           <a:latin typeface="Arial"/>
                         </a:rPr>
-                        <a:t>$3,957</a:t>
+                        <a:t>$4,318</a:t>
                       </a:r>
                     </a:p>
                   </a:txBody>
@@ -8312,7 +8312,7 @@
                           </a:solidFill>
                           <a:latin typeface="Arial"/>
                         </a:rPr>
-                        <a:t>202</a:t>
+                        <a:t>215</a:t>
                       </a:r>
                     </a:p>
                   </a:txBody>
@@ -8349,7 +8349,7 @@
                           </a:solidFill>
                           <a:latin typeface="Arial"/>
                         </a:rPr>
-                        <a:t>$3,899</a:t>
+                        <a:t>$4,206</a:t>
                       </a:r>
                     </a:p>
                   </a:txBody>
@@ -8499,7 +8499,7 @@
                           </a:solidFill>
                           <a:latin typeface="Arial"/>
                         </a:rPr>
-                        <a:t>180</a:t>
+                        <a:t>202</a:t>
                       </a:r>
                     </a:p>
                   </a:txBody>
@@ -8536,7 +8536,7 @@
                           </a:solidFill>
                           <a:latin typeface="Arial"/>
                         </a:rPr>
-                        <a:t>$3,231</a:t>
+                        <a:t>$3,781</a:t>
                       </a:r>
                     </a:p>
                   </a:txBody>
@@ -8686,7 +8686,7 @@
                           </a:solidFill>
                           <a:latin typeface="Arial"/>
                         </a:rPr>
-                        <a:t>122</a:t>
+                        <a:t>132</a:t>
                       </a:r>
                     </a:p>
                   </a:txBody>
@@ -8723,7 +8723,7 @@
                           </a:solidFill>
                           <a:latin typeface="Arial"/>
                         </a:rPr>
-                        <a:t>$3,050</a:t>
+                        <a:t>$3,330</a:t>
                       </a:r>
                     </a:p>
                   </a:txBody>
@@ -8799,7 +8799,7 @@
                           </a:solidFill>
                           <a:latin typeface="Arial"/>
                         </a:rPr>
-                        <a:t>B16 → B17</a:t>
+                        <a:t>B19 → B09</a:t>
                       </a:r>
                     </a:p>
                   </a:txBody>
@@ -8873,7 +8873,7 @@
                           </a:solidFill>
                           <a:latin typeface="Arial"/>
                         </a:rPr>
-                        <a:t>185</a:t>
+                        <a:t>216</a:t>
                       </a:r>
                     </a:p>
                   </a:txBody>
@@ -8910,7 +8910,7 @@
                           </a:solidFill>
                           <a:latin typeface="Arial"/>
                         </a:rPr>
-                        <a:t>$3,015</a:t>
+                        <a:t>$3,249</a:t>
                       </a:r>
                     </a:p>
                   </a:txBody>
@@ -9097,7 +9097,7 @@
                 </a:solidFill>
                 <a:latin typeface="Arial"/>
               </a:rPr>
-              <a:t>Rebalancing frees $1.1M of excess and avoids 84% of expected lost sales</a:t>
+              <a:t>Rebalancing frees $1.2M of excess and avoids 85% of expected lost sales</a:t>
             </a:r>
           </a:p>
         </p:txBody>
@@ -9274,7 +9274,7 @@
                 </a:solidFill>
                 <a:latin typeface="Arial"/>
               </a:rPr>
-              <a:t>$1.1M</a:t>
+              <a:t>$1.2M</a:t>
             </a:r>
           </a:p>
         </p:txBody>
@@ -9345,7 +9345,7 @@
                 </a:solidFill>
                 <a:latin typeface="Arial"/>
               </a:rPr>
-              <a:t>8,172 lost-sale units avoided</a:t>
+              <a:t>8,948 lost-sale units avoided</a:t>
             </a:r>
           </a:p>
         </p:txBody>
@@ -9580,7 +9580,7 @@
                           </a:solidFill>
                           <a:latin typeface="Arial"/>
                         </a:rPr>
-                        <a:t>$7.2M</a:t>
+                        <a:t>$7.1M</a:t>
                       </a:r>
                     </a:p>
                   </a:txBody>
@@ -9693,7 +9693,7 @@
                           </a:solidFill>
                           <a:latin typeface="Arial"/>
                         </a:rPr>
-                        <a:t>$1.92M</a:t>
+                        <a:t>$1.90M</a:t>
                       </a:r>
                     </a:p>
                   </a:txBody>
@@ -9769,7 +9769,7 @@
                           </a:solidFill>
                           <a:latin typeface="Arial"/>
                         </a:rPr>
-                        <a:t>9,725</a:t>
+                        <a:t>10,533</a:t>
                       </a:r>
                     </a:p>
                   </a:txBody>
@@ -9806,7 +9806,7 @@
                           </a:solidFill>
                           <a:latin typeface="Arial"/>
                         </a:rPr>
-                        <a:t>1,552</a:t>
+                        <a:t>1,585</a:t>
                       </a:r>
                     </a:p>
                   </a:txBody>
@@ -9882,7 +9882,7 @@
                           </a:solidFill>
                           <a:latin typeface="Arial"/>
                         </a:rPr>
-                        <a:t>411</a:t>
+                        <a:t>419</a:t>
                       </a:r>
                     </a:p>
                   </a:txBody>
@@ -9919,7 +9919,7 @@
                           </a:solidFill>
                           <a:latin typeface="Arial"/>
                         </a:rPr>
-                        <a:t>72</a:t>
+                        <a:t>76</a:t>
                       </a:r>
                     </a:p>
                   </a:txBody>
@@ -9995,7 +9995,7 @@
                           </a:solidFill>
                           <a:latin typeface="Arial"/>
                         </a:rPr>
-                        <a:t>8.4</a:t>
+                        <a:t>8.5</a:t>
                       </a:r>
                     </a:p>
                   </a:txBody>
@@ -10032,7 +10032,7 @@
                           </a:solidFill>
                           <a:latin typeface="Arial"/>
                         </a:rPr>
-                        <a:t>8.9</a:t>
+                        <a:t>9.0</a:t>
                       </a:r>
                     </a:p>
                   </a:txBody>
@@ -10145,7 +10145,7 @@
                           </a:solidFill>
                           <a:latin typeface="Arial"/>
                         </a:rPr>
-                        <a:t>$203k</a:t>
+                        <a:t>$216k</a:t>
                       </a:r>
                     </a:p>
                   </a:txBody>
@@ -10424,8 +10424,8 @@
         </p:blipFill>
         <p:spPr>
           <a:xfrm>
-            <a:off x="1508760" y="1600200"/>
-            <a:ext cx="4297680" cy="4343400"/>
+            <a:off x="1628377" y="1600200"/>
+            <a:ext cx="4058445" cy="4343400"/>
           </a:xfrm>
           <a:prstGeom prst="rect">
             <a:avLst/>
@@ -10464,7 +10464,7 @@
         </p:nvSpPr>
         <p:spPr>
           <a:xfrm>
-            <a:off x="1069848" y="1842516"/>
+            <a:off x="1189465" y="1842516"/>
             <a:ext cx="384048" cy="384048"/>
           </a:xfrm>
           <a:prstGeom prst="ellipse">
@@ -10505,7 +10505,7 @@
         </p:nvSpPr>
         <p:spPr>
           <a:xfrm>
-            <a:off x="3336645" y="4405122"/>
+            <a:off x="3343822" y="4405122"/>
             <a:ext cx="384048" cy="384048"/>
           </a:xfrm>
           <a:prstGeom prst="ellipse">

</xml_diff>

<commit_message>
Add challenges, lessons and next-with-more-resources slides; update script
</commit_message>
<xml_diff>
--- a/presentation/Stockflow_Stryker.pptx
+++ b/presentation/Stockflow_Stryker.pptx
@@ -13,6 +13,9 @@
     <p:sldId id="261" r:id="rId13"/>
     <p:sldId id="262" r:id="rId14"/>
     <p:sldId id="263" r:id="rId15"/>
+    <p:sldId id="264" r:id="rId16"/>
+    <p:sldId id="265" r:id="rId17"/>
+    <p:sldId id="266" r:id="rId18"/>
   </p:sldIdLst>
   <p:sldSz cx="12191695" cy="6858000" type="screen4x3"/>
   <p:notesSz cx="6858000" cy="9144000"/>
@@ -560,6 +563,206 @@
 </p:notes>
 </file>
 
+<file path=ppt/notesSlides/notesSlide10.xml><?xml version="1.0" encoding="utf-8"?>
+<p:notes xmlns:a="http://schemas.openxmlformats.org/drawingml/2006/main" xmlns:p="http://schemas.openxmlformats.org/presentationml/2006/main" xmlns:r="http://schemas.openxmlformats.org/officeDocument/2006/relationships">
+  <p:cSld>
+    <p:spTree>
+      <p:nvGrpSpPr>
+        <p:cNvPr id="1" name=""/>
+        <p:cNvGrpSpPr/>
+        <p:nvPr/>
+      </p:nvGrpSpPr>
+      <p:grpSpPr>
+        <a:xfrm>
+          <a:off x="0" y="0"/>
+          <a:ext cx="0" cy="0"/>
+          <a:chOff x="0" y="0"/>
+          <a:chExt cx="0" cy="0"/>
+        </a:xfrm>
+      </p:grpSpPr>
+      <p:sp>
+        <p:nvSpPr>
+          <p:cNvPr id="2" name="Slide Image Placeholder 1"/>
+          <p:cNvSpPr>
+            <a:spLocks noGrp="1"/>
+          </p:cNvSpPr>
+          <p:nvPr>
+            <p:ph type="sldImg" idx="2"/>
+          </p:nvPr>
+        </p:nvSpPr>
+        <p:spPr/>
+      </p:sp>
+      <p:sp>
+        <p:nvSpPr>
+          <p:cNvPr id="3" name="Notes Placeholder 2"/>
+          <p:cNvSpPr>
+            <a:spLocks noGrp="1"/>
+          </p:cNvSpPr>
+          <p:nvPr>
+            <p:ph type="body" idx="3" sz="quarter"/>
+          </p:nvPr>
+        </p:nvSpPr>
+        <p:spPr/>
+        <p:txBody>
+          <a:bodyPr/>
+          <a:lstStyle/>
+          <a:p>
+            <a:r>
+              <a:t>If I had more time and resources, four things come first.</a:t>
+            </a:r>
+          </a:p>
+          <a:p/>
+          <a:p>
+            <a:r>
+              <a:t>First, real data. Everything so far runs on synthetic data, so the first priority is real ERP extracts and agreeing the cost settings with finance, especially the cost of a lost sale.</a:t>
+            </a:r>
+          </a:p>
+          <a:p/>
+          <a:p>
+            <a:r>
+              <a:t>Second, plan further ahead. Today the tool plans one replenishment cycle. With more time I'd plan transfers and purchase orders together over several weeks, so the network isn't just moving stock around but deciding what to buy as well.</a:t>
+            </a:r>
+          </a:p>
+          <a:p/>
+          <a:p>
+            <a:r>
+              <a:t>Third, better uncertainty. Safety stock currently assumes forecast errors follow a normal distribution, and lead times are fixed. I'd use the model's own forecast ranges and real lead-time variability instead, which matters most for the slow, lumpy items.</a:t>
+            </a:r>
+          </a:p>
+          <a:p/>
+          <a:p>
+            <a:r>
+              <a:t>Fourth, close the loop. Approved transfers would be raised in the ERP automatically, retraining would run on a schedule, and every planner rejection would feed back into the cost settings, so the tool learns where its assumptions are wrong.</a:t>
+            </a:r>
+          </a:p>
+        </p:txBody>
+      </p:sp>
+      <p:sp>
+        <p:nvSpPr>
+          <p:cNvPr id="4" name="Slide Number Placeholder 3"/>
+          <p:cNvSpPr>
+            <a:spLocks noGrp="1"/>
+          </p:cNvSpPr>
+          <p:nvPr>
+            <p:ph type="sldNum" idx="5" sz="quarter"/>
+          </p:nvPr>
+        </p:nvSpPr>
+        <p:spPr/>
+      </p:sp>
+    </p:spTree>
+  </p:cSld>
+  <p:clrMapOvr>
+    <a:masterClrMapping/>
+  </p:clrMapOvr>
+</p:notes>
+</file>
+
+<file path=ppt/notesSlides/notesSlide11.xml><?xml version="1.0" encoding="utf-8"?>
+<p:notes xmlns:a="http://schemas.openxmlformats.org/drawingml/2006/main" xmlns:p="http://schemas.openxmlformats.org/presentationml/2006/main" xmlns:r="http://schemas.openxmlformats.org/officeDocument/2006/relationships">
+  <p:cSld>
+    <p:spTree>
+      <p:nvGrpSpPr>
+        <p:cNvPr id="1" name=""/>
+        <p:cNvGrpSpPr/>
+        <p:nvPr/>
+      </p:nvGrpSpPr>
+      <p:grpSpPr>
+        <a:xfrm>
+          <a:off x="0" y="0"/>
+          <a:ext cx="0" cy="0"/>
+          <a:chOff x="0" y="0"/>
+          <a:chExt cx="0" cy="0"/>
+        </a:xfrm>
+      </p:grpSpPr>
+      <p:sp>
+        <p:nvSpPr>
+          <p:cNvPr id="2" name="Slide Image Placeholder 1"/>
+          <p:cNvSpPr>
+            <a:spLocks noGrp="1"/>
+          </p:cNvSpPr>
+          <p:nvPr>
+            <p:ph type="sldImg" idx="2"/>
+          </p:nvPr>
+        </p:nvSpPr>
+        <p:spPr/>
+      </p:sp>
+      <p:sp>
+        <p:nvSpPr>
+          <p:cNvPr id="3" name="Notes Placeholder 2"/>
+          <p:cNvSpPr>
+            <a:spLocks noGrp="1"/>
+          </p:cNvSpPr>
+          <p:nvPr>
+            <p:ph type="body" idx="3" sz="quarter"/>
+          </p:nvPr>
+        </p:nvSpPr>
+        <p:spPr/>
+        <p:txBody>
+          <a:bodyPr/>
+          <a:lstStyle/>
+          <a:p>
+            <a:r>
+              <a:t>To move from a demonstration to a decision, I'd propose a 12-week pilot.</a:t>
+            </a:r>
+          </a:p>
+          <a:p/>
+          <a:p>
+            <a:r>
+              <a:t>Weeks one to four: connect real data. The tool reads seven standard extracts (sales, stock movements, open orders, promotions, branch and product masters, lane costs), all documented in the repository with validation rules, so a bad file is rejected with a clear message instead of a wrong answer.</a:t>
+            </a:r>
+          </a:p>
+          <a:p/>
+          <a:p>
+            <a:r>
+              <a:t>Weeks five to ten: run it in shadow mode at two or three branches. Planners see the recommendations, approve or reject them, and we compare what the tool suggested with what actually happened. Rejections are valuable: they tell us where the cost assumptions are wrong.</a:t>
+            </a:r>
+          </a:p>
+          <a:p/>
+          <a:p>
+            <a:r>
+              <a:t>Weeks eleven and twelve: decide. Monitoring is already built: weekly checks of forecast error and bias against the baseline, data drift, and an alert that triggers retraining.</a:t>
+            </a:r>
+          </a:p>
+          <a:p/>
+          <a:p>
+            <a:r>
+              <a:t>The limitations, stated plainly: the data so far is synthetic; the plan looks one replenishment cycle ahead, not a multi-week schedule; safety stock assumes a normal error distribution; and the cost settings, like the price of a lost sale, need sign-off from finance before any dollar figure is trusted.</a:t>
+            </a:r>
+          </a:p>
+          <a:p/>
+          <a:p>
+            <a:r>
+              <a:t>To close where we started: getting the right product to the right branch is one concrete way we make healthcare better with our customers. Surgeons don't wait, so patients don't either. Thank you; I'm happy to take questions.</a:t>
+            </a:r>
+          </a:p>
+          <a:p/>
+          <a:p>
+            <a:r>
+              <a:t>Likely question: "What would you need from us?" Answer: read-only extracts for two or three branches, a planner willing to review recommendations weekly, and thirty minutes with finance on the cost settings.</a:t>
+            </a:r>
+          </a:p>
+        </p:txBody>
+      </p:sp>
+      <p:sp>
+        <p:nvSpPr>
+          <p:cNvPr id="4" name="Slide Number Placeholder 3"/>
+          <p:cNvSpPr>
+            <a:spLocks noGrp="1"/>
+          </p:cNvSpPr>
+          <p:nvPr>
+            <p:ph type="sldNum" idx="5" sz="quarter"/>
+          </p:nvPr>
+        </p:nvSpPr>
+        <p:spPr/>
+      </p:sp>
+    </p:spTree>
+  </p:cSld>
+  <p:clrMapOvr>
+    <a:masterClrMapping/>
+  </p:clrMapOvr>
+</p:notes>
+</file>
+
 <file path=ppt/notesSlides/notesSlide2.xml><?xml version="1.0" encoding="utf-8"?>
 <p:notes xmlns:a="http://schemas.openxmlformats.org/drawingml/2006/main" xmlns:p="http://schemas.openxmlformats.org/presentationml/2006/main" xmlns:r="http://schemas.openxmlformats.org/officeDocument/2006/relationships">
   <p:cSld>
@@ -1199,43 +1402,125 @@
           <a:lstStyle/>
           <a:p>
             <a:r>
-              <a:t>To move from a demonstration to a decision, I'd propose a 12-week pilot.</a:t>
+              <a:t>Now that you've seen the result, I want to be honest about what was hard, because that's where most of the learning happened.</a:t>
             </a:r>
           </a:p>
           <a:p/>
           <a:p>
             <a:r>
-              <a:t>Weeks one to four: connect real data. The tool reads seven standard extracts (sales, stock movements, open orders, promotions, branch and product masters, lane costs), all documented in the repository with validation rules, so a bad file is rejected with a clear message instead of a wrong answer.</a:t>
+              <a:t>First, the data lies on stock-out days. When the shelf is empty, sales are zero, but demand isn't. That happened on 5.8% of branch-product days. If I'd trained on those days, the model would learn that demand is lower than it really is, and keep ordering too little. So I flag those days and exclude them from training and scoring.</a:t>
             </a:r>
           </a:p>
           <a:p/>
           <a:p>
             <a:r>
-              <a:t>Weeks five to ten: run it in shadow mode at two or three branches. Planners see the recommendations, approve or reject them, and we compare what the tool suggested with what actually happened. Rejections are valuable: they tell us where the cost assumptions are wrong.</a:t>
+              <a:t>Second, the forecast bias. At 10 times the network size, the forecast ran 2.6% low. My first theory, the way I sampled training data, was wrong, and I proved that with an experiment before building anything. The real fix was a per-segment correction learned only from earlier months. Bias went to -0.8%, and to zero at normal scale.</a:t>
             </a:r>
           </a:p>
           <a:p/>
           <a:p>
             <a:r>
-              <a:t>Weeks eleven and twelve: decide. Monitoring is already built: weekly checks of forecast error and bias against the baseline, data drift, and an alert that triggers retraining.</a:t>
+              <a:t>Third, scale. Every product can move between every pair of branches, so the optimization grows very fast. I pruned routes that could never pay for themselves and split the problem into product batches that solve in parallel. At 10 times scale that's 160 batches in about 15 minutes.</a:t>
             </a:r>
           </a:p>
           <a:p/>
           <a:p>
             <a:r>
-              <a:t>The limitations, stated plainly: the data so far is synthetic; the plan looks one replenishment cycle ahead, not a multi-week schedule; safety stock assumes a normal error distribution; and the cost settings, like the price of a lost sale, need sign-off from finance before any dollar figure is trusted.</a:t>
+              <a:t>Fourth, and maybe the hardest: trust. A planner won't act on a list of numbers from a model. So every transfer carries a plain-language reason, nothing moves without approval, and the sensitivity check shows the plan holds when the assumptions change.</a:t>
+            </a:r>
+          </a:p>
+        </p:txBody>
+      </p:sp>
+      <p:sp>
+        <p:nvSpPr>
+          <p:cNvPr id="4" name="Slide Number Placeholder 3"/>
+          <p:cNvSpPr>
+            <a:spLocks noGrp="1"/>
+          </p:cNvSpPr>
+          <p:nvPr>
+            <p:ph type="sldNum" idx="5" sz="quarter"/>
+          </p:nvPr>
+        </p:nvSpPr>
+        <p:spPr/>
+      </p:sp>
+    </p:spTree>
+  </p:cSld>
+  <p:clrMapOvr>
+    <a:masterClrMapping/>
+  </p:clrMapOvr>
+</p:notes>
+</file>
+
+<file path=ppt/notesSlides/notesSlide9.xml><?xml version="1.0" encoding="utf-8"?>
+<p:notes xmlns:a="http://schemas.openxmlformats.org/drawingml/2006/main" xmlns:p="http://schemas.openxmlformats.org/presentationml/2006/main" xmlns:r="http://schemas.openxmlformats.org/officeDocument/2006/relationships">
+  <p:cSld>
+    <p:spTree>
+      <p:nvGrpSpPr>
+        <p:cNvPr id="1" name=""/>
+        <p:cNvGrpSpPr/>
+        <p:nvPr/>
+      </p:nvGrpSpPr>
+      <p:grpSpPr>
+        <a:xfrm>
+          <a:off x="0" y="0"/>
+          <a:ext cx="0" cy="0"/>
+          <a:chOff x="0" y="0"/>
+          <a:chExt cx="0" cy="0"/>
+        </a:xfrm>
+      </p:grpSpPr>
+      <p:sp>
+        <p:nvSpPr>
+          <p:cNvPr id="2" name="Slide Image Placeholder 1"/>
+          <p:cNvSpPr>
+            <a:spLocks noGrp="1"/>
+          </p:cNvSpPr>
+          <p:nvPr>
+            <p:ph type="sldImg" idx="2"/>
+          </p:nvPr>
+        </p:nvSpPr>
+        <p:spPr/>
+      </p:sp>
+      <p:sp>
+        <p:nvSpPr>
+          <p:cNvPr id="3" name="Notes Placeholder 2"/>
+          <p:cNvSpPr>
+            <a:spLocks noGrp="1"/>
+          </p:cNvSpPr>
+          <p:nvPr>
+            <p:ph type="body" idx="3" sz="quarter"/>
+          </p:nvPr>
+        </p:nvSpPr>
+        <p:spPr/>
+        <p:txBody>
+          <a:bodyPr/>
+          <a:lstStyle/>
+          <a:p>
+            <a:r>
+              <a:t>Four things I'll take into my next project.</a:t>
             </a:r>
           </a:p>
           <a:p/>
           <a:p>
             <a:r>
-              <a:t>To close where we started: getting the right product to the right branch is one concrete way we make healthcare better with our customers. Surgeons don't wait, so patients don't either. Thank you; I'm happy to take questions.</a:t>
+              <a:t>One: test the hypothesis before building the fix. With the bias, my first instinct was wrong. A quick experiment saved me from building a fix for the wrong problem.</a:t>
             </a:r>
           </a:p>
           <a:p/>
           <a:p>
             <a:r>
-              <a:t>Likely question: "What would you need from us?" Answer: read-only extracts for two or three branches, a planner willing to review recommendations weekly, and thirty minutes with finance on the cost settings.</a:t>
+              <a:t>Two: the simple baseline is the bar to beat, and you should say where you lose. The model beats every baseline overall, but it still loses on 19% of individual series, mostly slow movers, and the dashboard shows that. Being upfront about it made the rest of the numbers more credible.</a:t>
+            </a:r>
+          </a:p>
+          <a:p/>
+          <a:p>
+            <a:r>
+              <a:t>Three: explainability drives adoption more than accuracy. The plain-language reason on each transfer will matter more to a branch manager than one more point of accuracy.</a:t>
+            </a:r>
+          </a:p>
+          <a:p/>
+          <a:p>
+            <a:r>
+              <a:t>Four: delete work that doesn't earn its place. I built a branch-level correction on top of the segment one. It didn't help at scale and added noise, so I took it out. Less code, same result.</a:t>
             </a:r>
           </a:p>
         </p:txBody>
@@ -4652,6 +4937,1753 @@
 </p:sld>
 </file>
 
+<file path=ppt/slides/slide10.xml><?xml version="1.0" encoding="utf-8"?>
+<p:sld xmlns:a="http://schemas.openxmlformats.org/drawingml/2006/main" xmlns:p="http://schemas.openxmlformats.org/presentationml/2006/main" xmlns:r="http://schemas.openxmlformats.org/officeDocument/2006/relationships">
+  <p:cSld>
+    <p:spTree>
+      <p:nvGrpSpPr>
+        <p:cNvPr id="1" name=""/>
+        <p:cNvGrpSpPr/>
+        <p:nvPr/>
+      </p:nvGrpSpPr>
+      <p:grpSpPr/>
+      <p:sp>
+        <p:nvSpPr>
+          <p:cNvPr id="2" name="Rectangle 1"/>
+          <p:cNvSpPr/>
+          <p:nvPr/>
+        </p:nvSpPr>
+        <p:spPr>
+          <a:xfrm>
+            <a:off x="548640" y="384048"/>
+            <a:ext cx="822960" cy="82296"/>
+          </a:xfrm>
+          <a:prstGeom prst="rect">
+            <a:avLst/>
+          </a:prstGeom>
+          <a:solidFill>
+            <a:srgbClr val="FFB502"/>
+          </a:solidFill>
+          <a:ln>
+            <a:noFill/>
+          </a:ln>
+          <a:effectLst/>
+        </p:spPr>
+        <p:txBody>
+          <a:bodyPr rtlCol="0" anchor="ctr"/>
+          <a:lstStyle/>
+          <a:p>
+            <a:pPr algn="ctr"/>
+          </a:p>
+        </p:txBody>
+      </p:sp>
+      <p:sp>
+        <p:nvSpPr>
+          <p:cNvPr id="3" name="TextBox 2"/>
+          <p:cNvSpPr txBox="1"/>
+          <p:nvPr/>
+        </p:nvSpPr>
+        <p:spPr>
+          <a:xfrm>
+            <a:off x="548640" y="566928"/>
+            <a:ext cx="11094415" cy="914400"/>
+          </a:xfrm>
+          <a:prstGeom prst="rect">
+            <a:avLst/>
+          </a:prstGeom>
+          <a:noFill/>
+        </p:spPr>
+        <p:txBody>
+          <a:bodyPr wrap="square" lIns="0" rIns="0" tIns="0" bIns="0" anchor="t">
+            <a:spAutoFit/>
+          </a:bodyPr>
+          <a:lstStyle/>
+          <a:p>
+            <a:pPr algn="l">
+              <a:lnSpc>
+                <a:spcPct val="100000"/>
+              </a:lnSpc>
+            </a:pPr>
+            <a:r>
+              <a:rPr sz="2600" b="1">
+                <a:solidFill>
+                  <a:srgbClr val="000000"/>
+                </a:solidFill>
+                <a:latin typeface="Arial"/>
+              </a:rPr>
+              <a:t>With more time and resources: real data, longer horizons, and closing the loop</a:t>
+            </a:r>
+          </a:p>
+        </p:txBody>
+      </p:sp>
+      <p:sp>
+        <p:nvSpPr>
+          <p:cNvPr id="4" name="Rectangle 3"/>
+          <p:cNvSpPr/>
+          <p:nvPr/>
+        </p:nvSpPr>
+        <p:spPr>
+          <a:xfrm>
+            <a:off x="548640" y="6291072"/>
+            <a:ext cx="11094415" cy="9525"/>
+          </a:xfrm>
+          <a:prstGeom prst="rect">
+            <a:avLst/>
+          </a:prstGeom>
+          <a:solidFill>
+            <a:srgbClr val="D9D9D9"/>
+          </a:solidFill>
+          <a:ln>
+            <a:noFill/>
+          </a:ln>
+          <a:effectLst/>
+        </p:spPr>
+        <p:txBody>
+          <a:bodyPr rtlCol="0" anchor="ctr"/>
+          <a:lstStyle/>
+          <a:p>
+            <a:pPr algn="ctr"/>
+          </a:p>
+        </p:txBody>
+      </p:sp>
+      <p:sp>
+        <p:nvSpPr>
+          <p:cNvPr id="5" name="TextBox 4"/>
+          <p:cNvSpPr txBox="1"/>
+          <p:nvPr/>
+        </p:nvSpPr>
+        <p:spPr>
+          <a:xfrm>
+            <a:off x="548640" y="6400800"/>
+            <a:ext cx="5486400" cy="274320"/>
+          </a:xfrm>
+          <a:prstGeom prst="rect">
+            <a:avLst/>
+          </a:prstGeom>
+          <a:noFill/>
+        </p:spPr>
+        <p:txBody>
+          <a:bodyPr wrap="square" lIns="0" rIns="0" tIns="0" bIns="0" anchor="t">
+            <a:spAutoFit/>
+          </a:bodyPr>
+          <a:lstStyle/>
+          <a:p>
+            <a:pPr algn="l">
+              <a:lnSpc>
+                <a:spcPct val="110000"/>
+              </a:lnSpc>
+            </a:pPr>
+            <a:r>
+              <a:rPr sz="1000" b="0">
+                <a:solidFill>
+                  <a:srgbClr val="6E6E6E"/>
+                </a:solidFill>
+                <a:latin typeface="Arial"/>
+              </a:rPr>
+              <a:t>Synthetic data – for demonstration</a:t>
+            </a:r>
+          </a:p>
+        </p:txBody>
+      </p:sp>
+      <p:sp>
+        <p:nvSpPr>
+          <p:cNvPr id="6" name="TextBox 5"/>
+          <p:cNvSpPr txBox="1"/>
+          <p:nvPr/>
+        </p:nvSpPr>
+        <p:spPr>
+          <a:xfrm>
+            <a:off x="10728655" y="6400800"/>
+            <a:ext cx="914400" cy="274320"/>
+          </a:xfrm>
+          <a:prstGeom prst="rect">
+            <a:avLst/>
+          </a:prstGeom>
+          <a:noFill/>
+        </p:spPr>
+        <p:txBody>
+          <a:bodyPr wrap="square" lIns="0" rIns="0" tIns="0" bIns="0" anchor="t">
+            <a:spAutoFit/>
+          </a:bodyPr>
+          <a:lstStyle/>
+          <a:p>
+            <a:pPr algn="r">
+              <a:lnSpc>
+                <a:spcPct val="110000"/>
+              </a:lnSpc>
+            </a:pPr>
+            <a:r>
+              <a:rPr sz="1000" b="0">
+                <a:solidFill>
+                  <a:srgbClr val="6E6E6E"/>
+                </a:solidFill>
+                <a:latin typeface="Arial"/>
+              </a:rPr>
+              <a:t>10</a:t>
+            </a:r>
+          </a:p>
+        </p:txBody>
+      </p:sp>
+      <p:sp>
+        <p:nvSpPr>
+          <p:cNvPr id="7" name="Rectangle 6"/>
+          <p:cNvSpPr/>
+          <p:nvPr/>
+        </p:nvSpPr>
+        <p:spPr>
+          <a:xfrm>
+            <a:off x="548640" y="1645920"/>
+            <a:ext cx="5364327" cy="2080260"/>
+          </a:xfrm>
+          <a:prstGeom prst="rect">
+            <a:avLst/>
+          </a:prstGeom>
+          <a:solidFill>
+            <a:srgbClr val="F2F2F2"/>
+          </a:solidFill>
+          <a:ln>
+            <a:noFill/>
+          </a:ln>
+          <a:effectLst/>
+        </p:spPr>
+        <p:txBody>
+          <a:bodyPr rtlCol="0" anchor="ctr"/>
+          <a:lstStyle/>
+          <a:p>
+            <a:pPr algn="ctr"/>
+          </a:p>
+        </p:txBody>
+      </p:sp>
+      <p:sp>
+        <p:nvSpPr>
+          <p:cNvPr id="8" name="Rectangle 7"/>
+          <p:cNvSpPr/>
+          <p:nvPr/>
+        </p:nvSpPr>
+        <p:spPr>
+          <a:xfrm>
+            <a:off x="548640" y="1645920"/>
+            <a:ext cx="82296" cy="2080260"/>
+          </a:xfrm>
+          <a:prstGeom prst="rect">
+            <a:avLst/>
+          </a:prstGeom>
+          <a:solidFill>
+            <a:srgbClr val="FFB502"/>
+          </a:solidFill>
+          <a:ln>
+            <a:noFill/>
+          </a:ln>
+          <a:effectLst/>
+        </p:spPr>
+        <p:txBody>
+          <a:bodyPr rtlCol="0" anchor="ctr"/>
+          <a:lstStyle/>
+          <a:p>
+            <a:pPr algn="ctr"/>
+          </a:p>
+        </p:txBody>
+      </p:sp>
+      <p:sp>
+        <p:nvSpPr>
+          <p:cNvPr id="9" name="TextBox 8"/>
+          <p:cNvSpPr txBox="1"/>
+          <p:nvPr/>
+        </p:nvSpPr>
+        <p:spPr>
+          <a:xfrm>
+            <a:off x="822960" y="1828800"/>
+            <a:ext cx="4861407" cy="457200"/>
+          </a:xfrm>
+          <a:prstGeom prst="rect">
+            <a:avLst/>
+          </a:prstGeom>
+          <a:noFill/>
+        </p:spPr>
+        <p:txBody>
+          <a:bodyPr wrap="square" lIns="0" rIns="0" tIns="0" bIns="0" anchor="t">
+            <a:spAutoFit/>
+          </a:bodyPr>
+          <a:lstStyle/>
+          <a:p>
+            <a:pPr algn="l">
+              <a:lnSpc>
+                <a:spcPct val="110000"/>
+              </a:lnSpc>
+            </a:pPr>
+            <a:r>
+              <a:rPr sz="1900" b="1">
+                <a:solidFill>
+                  <a:srgbClr val="000000"/>
+                </a:solidFill>
+                <a:latin typeface="Arial"/>
+              </a:rPr>
+              <a:t>Real data and agreed costs</a:t>
+            </a:r>
+          </a:p>
+        </p:txBody>
+      </p:sp>
+      <p:sp>
+        <p:nvSpPr>
+          <p:cNvPr id="10" name="TextBox 9"/>
+          <p:cNvSpPr txBox="1"/>
+          <p:nvPr/>
+        </p:nvSpPr>
+        <p:spPr>
+          <a:xfrm>
+            <a:off x="822960" y="2377440"/>
+            <a:ext cx="4861407" cy="1211580"/>
+          </a:xfrm>
+          <a:prstGeom prst="rect">
+            <a:avLst/>
+          </a:prstGeom>
+          <a:noFill/>
+        </p:spPr>
+        <p:txBody>
+          <a:bodyPr wrap="square" lIns="0" rIns="0" tIns="0" bIns="0" anchor="t">
+            <a:spAutoFit/>
+          </a:bodyPr>
+          <a:lstStyle/>
+          <a:p>
+            <a:pPr algn="l">
+              <a:lnSpc>
+                <a:spcPct val="120000"/>
+              </a:lnSpc>
+            </a:pPr>
+            <a:r>
+              <a:rPr sz="1500" b="0">
+                <a:solidFill>
+                  <a:srgbClr val="333333"/>
+                </a:solidFill>
+                <a:latin typeface="Arial"/>
+              </a:rPr>
+              <a:t>Run on real ERP extracts, and agree the cost of a lost sale and freight rates with finance.</a:t>
+            </a:r>
+          </a:p>
+        </p:txBody>
+      </p:sp>
+      <p:sp>
+        <p:nvSpPr>
+          <p:cNvPr id="11" name="Rectangle 10"/>
+          <p:cNvSpPr/>
+          <p:nvPr/>
+        </p:nvSpPr>
+        <p:spPr>
+          <a:xfrm>
+            <a:off x="6278727" y="1645920"/>
+            <a:ext cx="5364327" cy="2080260"/>
+          </a:xfrm>
+          <a:prstGeom prst="rect">
+            <a:avLst/>
+          </a:prstGeom>
+          <a:solidFill>
+            <a:srgbClr val="F2F2F2"/>
+          </a:solidFill>
+          <a:ln>
+            <a:noFill/>
+          </a:ln>
+          <a:effectLst/>
+        </p:spPr>
+        <p:txBody>
+          <a:bodyPr rtlCol="0" anchor="ctr"/>
+          <a:lstStyle/>
+          <a:p>
+            <a:pPr algn="ctr"/>
+          </a:p>
+        </p:txBody>
+      </p:sp>
+      <p:sp>
+        <p:nvSpPr>
+          <p:cNvPr id="12" name="Rectangle 11"/>
+          <p:cNvSpPr/>
+          <p:nvPr/>
+        </p:nvSpPr>
+        <p:spPr>
+          <a:xfrm>
+            <a:off x="6278727" y="1645920"/>
+            <a:ext cx="82296" cy="2080260"/>
+          </a:xfrm>
+          <a:prstGeom prst="rect">
+            <a:avLst/>
+          </a:prstGeom>
+          <a:solidFill>
+            <a:srgbClr val="333333"/>
+          </a:solidFill>
+          <a:ln>
+            <a:noFill/>
+          </a:ln>
+          <a:effectLst/>
+        </p:spPr>
+        <p:txBody>
+          <a:bodyPr rtlCol="0" anchor="ctr"/>
+          <a:lstStyle/>
+          <a:p>
+            <a:pPr algn="ctr"/>
+          </a:p>
+        </p:txBody>
+      </p:sp>
+      <p:sp>
+        <p:nvSpPr>
+          <p:cNvPr id="13" name="TextBox 12"/>
+          <p:cNvSpPr txBox="1"/>
+          <p:nvPr/>
+        </p:nvSpPr>
+        <p:spPr>
+          <a:xfrm>
+            <a:off x="6553047" y="1828800"/>
+            <a:ext cx="4861407" cy="457200"/>
+          </a:xfrm>
+          <a:prstGeom prst="rect">
+            <a:avLst/>
+          </a:prstGeom>
+          <a:noFill/>
+        </p:spPr>
+        <p:txBody>
+          <a:bodyPr wrap="square" lIns="0" rIns="0" tIns="0" bIns="0" anchor="t">
+            <a:spAutoFit/>
+          </a:bodyPr>
+          <a:lstStyle/>
+          <a:p>
+            <a:pPr algn="l">
+              <a:lnSpc>
+                <a:spcPct val="110000"/>
+              </a:lnSpc>
+            </a:pPr>
+            <a:r>
+              <a:rPr sz="1900" b="1">
+                <a:solidFill>
+                  <a:srgbClr val="000000"/>
+                </a:solidFill>
+                <a:latin typeface="Arial"/>
+              </a:rPr>
+              <a:t>Plan weeks ahead, not one cycle</a:t>
+            </a:r>
+          </a:p>
+        </p:txBody>
+      </p:sp>
+      <p:sp>
+        <p:nvSpPr>
+          <p:cNvPr id="14" name="TextBox 13"/>
+          <p:cNvSpPr txBox="1"/>
+          <p:nvPr/>
+        </p:nvSpPr>
+        <p:spPr>
+          <a:xfrm>
+            <a:off x="6553047" y="2377440"/>
+            <a:ext cx="4861407" cy="1211580"/>
+          </a:xfrm>
+          <a:prstGeom prst="rect">
+            <a:avLst/>
+          </a:prstGeom>
+          <a:noFill/>
+        </p:spPr>
+        <p:txBody>
+          <a:bodyPr wrap="square" lIns="0" rIns="0" tIns="0" bIns="0" anchor="t">
+            <a:spAutoFit/>
+          </a:bodyPr>
+          <a:lstStyle/>
+          <a:p>
+            <a:pPr algn="l">
+              <a:lnSpc>
+                <a:spcPct val="120000"/>
+              </a:lnSpc>
+            </a:pPr>
+            <a:r>
+              <a:rPr sz="1500" b="0">
+                <a:solidFill>
+                  <a:srgbClr val="333333"/>
+                </a:solidFill>
+                <a:latin typeface="Arial"/>
+              </a:rPr>
+              <a:t>Optimize transfers and purchase orders together over several weeks.</a:t>
+            </a:r>
+          </a:p>
+        </p:txBody>
+      </p:sp>
+      <p:sp>
+        <p:nvSpPr>
+          <p:cNvPr id="15" name="Rectangle 14"/>
+          <p:cNvSpPr/>
+          <p:nvPr/>
+        </p:nvSpPr>
+        <p:spPr>
+          <a:xfrm>
+            <a:off x="548640" y="4000500"/>
+            <a:ext cx="5364327" cy="2080260"/>
+          </a:xfrm>
+          <a:prstGeom prst="rect">
+            <a:avLst/>
+          </a:prstGeom>
+          <a:solidFill>
+            <a:srgbClr val="F2F2F2"/>
+          </a:solidFill>
+          <a:ln>
+            <a:noFill/>
+          </a:ln>
+          <a:effectLst/>
+        </p:spPr>
+        <p:txBody>
+          <a:bodyPr rtlCol="0" anchor="ctr"/>
+          <a:lstStyle/>
+          <a:p>
+            <a:pPr algn="ctr"/>
+          </a:p>
+        </p:txBody>
+      </p:sp>
+      <p:sp>
+        <p:nvSpPr>
+          <p:cNvPr id="16" name="Rectangle 15"/>
+          <p:cNvSpPr/>
+          <p:nvPr/>
+        </p:nvSpPr>
+        <p:spPr>
+          <a:xfrm>
+            <a:off x="548640" y="4000500"/>
+            <a:ext cx="82296" cy="2080260"/>
+          </a:xfrm>
+          <a:prstGeom prst="rect">
+            <a:avLst/>
+          </a:prstGeom>
+          <a:solidFill>
+            <a:srgbClr val="333333"/>
+          </a:solidFill>
+          <a:ln>
+            <a:noFill/>
+          </a:ln>
+          <a:effectLst/>
+        </p:spPr>
+        <p:txBody>
+          <a:bodyPr rtlCol="0" anchor="ctr"/>
+          <a:lstStyle/>
+          <a:p>
+            <a:pPr algn="ctr"/>
+          </a:p>
+        </p:txBody>
+      </p:sp>
+      <p:sp>
+        <p:nvSpPr>
+          <p:cNvPr id="17" name="TextBox 16"/>
+          <p:cNvSpPr txBox="1"/>
+          <p:nvPr/>
+        </p:nvSpPr>
+        <p:spPr>
+          <a:xfrm>
+            <a:off x="822960" y="4183380"/>
+            <a:ext cx="4861407" cy="457200"/>
+          </a:xfrm>
+          <a:prstGeom prst="rect">
+            <a:avLst/>
+          </a:prstGeom>
+          <a:noFill/>
+        </p:spPr>
+        <p:txBody>
+          <a:bodyPr wrap="square" lIns="0" rIns="0" tIns="0" bIns="0" anchor="t">
+            <a:spAutoFit/>
+          </a:bodyPr>
+          <a:lstStyle/>
+          <a:p>
+            <a:pPr algn="l">
+              <a:lnSpc>
+                <a:spcPct val="110000"/>
+              </a:lnSpc>
+            </a:pPr>
+            <a:r>
+              <a:rPr sz="1900" b="1">
+                <a:solidFill>
+                  <a:srgbClr val="000000"/>
+                </a:solidFill>
+                <a:latin typeface="Arial"/>
+              </a:rPr>
+              <a:t>Better uncertainty</a:t>
+            </a:r>
+          </a:p>
+        </p:txBody>
+      </p:sp>
+      <p:sp>
+        <p:nvSpPr>
+          <p:cNvPr id="18" name="TextBox 17"/>
+          <p:cNvSpPr txBox="1"/>
+          <p:nvPr/>
+        </p:nvSpPr>
+        <p:spPr>
+          <a:xfrm>
+            <a:off x="822960" y="4732020"/>
+            <a:ext cx="4861407" cy="1211580"/>
+          </a:xfrm>
+          <a:prstGeom prst="rect">
+            <a:avLst/>
+          </a:prstGeom>
+          <a:noFill/>
+        </p:spPr>
+        <p:txBody>
+          <a:bodyPr wrap="square" lIns="0" rIns="0" tIns="0" bIns="0" anchor="t">
+            <a:spAutoFit/>
+          </a:bodyPr>
+          <a:lstStyle/>
+          <a:p>
+            <a:pPr algn="l">
+              <a:lnSpc>
+                <a:spcPct val="120000"/>
+              </a:lnSpc>
+            </a:pPr>
+            <a:r>
+              <a:rPr sz="1500" b="0">
+                <a:solidFill>
+                  <a:srgbClr val="333333"/>
+                </a:solidFill>
+                <a:latin typeface="Arial"/>
+              </a:rPr>
+              <a:t>Use the model's own forecast ranges and real lead-time variability for safety stock, not a normal error model.</a:t>
+            </a:r>
+          </a:p>
+        </p:txBody>
+      </p:sp>
+      <p:sp>
+        <p:nvSpPr>
+          <p:cNvPr id="19" name="Rectangle 18"/>
+          <p:cNvSpPr/>
+          <p:nvPr/>
+        </p:nvSpPr>
+        <p:spPr>
+          <a:xfrm>
+            <a:off x="6278727" y="4000500"/>
+            <a:ext cx="5364327" cy="2080260"/>
+          </a:xfrm>
+          <a:prstGeom prst="rect">
+            <a:avLst/>
+          </a:prstGeom>
+          <a:solidFill>
+            <a:srgbClr val="F2F2F2"/>
+          </a:solidFill>
+          <a:ln>
+            <a:noFill/>
+          </a:ln>
+          <a:effectLst/>
+        </p:spPr>
+        <p:txBody>
+          <a:bodyPr rtlCol="0" anchor="ctr"/>
+          <a:lstStyle/>
+          <a:p>
+            <a:pPr algn="ctr"/>
+          </a:p>
+        </p:txBody>
+      </p:sp>
+      <p:sp>
+        <p:nvSpPr>
+          <p:cNvPr id="20" name="Rectangle 19"/>
+          <p:cNvSpPr/>
+          <p:nvPr/>
+        </p:nvSpPr>
+        <p:spPr>
+          <a:xfrm>
+            <a:off x="6278727" y="4000500"/>
+            <a:ext cx="82296" cy="2080260"/>
+          </a:xfrm>
+          <a:prstGeom prst="rect">
+            <a:avLst/>
+          </a:prstGeom>
+          <a:solidFill>
+            <a:srgbClr val="FFB502"/>
+          </a:solidFill>
+          <a:ln>
+            <a:noFill/>
+          </a:ln>
+          <a:effectLst/>
+        </p:spPr>
+        <p:txBody>
+          <a:bodyPr rtlCol="0" anchor="ctr"/>
+          <a:lstStyle/>
+          <a:p>
+            <a:pPr algn="ctr"/>
+          </a:p>
+        </p:txBody>
+      </p:sp>
+      <p:sp>
+        <p:nvSpPr>
+          <p:cNvPr id="21" name="TextBox 20"/>
+          <p:cNvSpPr txBox="1"/>
+          <p:nvPr/>
+        </p:nvSpPr>
+        <p:spPr>
+          <a:xfrm>
+            <a:off x="6553047" y="4183380"/>
+            <a:ext cx="4861407" cy="457200"/>
+          </a:xfrm>
+          <a:prstGeom prst="rect">
+            <a:avLst/>
+          </a:prstGeom>
+          <a:noFill/>
+        </p:spPr>
+        <p:txBody>
+          <a:bodyPr wrap="square" lIns="0" rIns="0" tIns="0" bIns="0" anchor="t">
+            <a:spAutoFit/>
+          </a:bodyPr>
+          <a:lstStyle/>
+          <a:p>
+            <a:pPr algn="l">
+              <a:lnSpc>
+                <a:spcPct val="110000"/>
+              </a:lnSpc>
+            </a:pPr>
+            <a:r>
+              <a:rPr sz="1900" b="1">
+                <a:solidFill>
+                  <a:srgbClr val="000000"/>
+                </a:solidFill>
+                <a:latin typeface="Arial"/>
+              </a:rPr>
+              <a:t>Close the loop</a:t>
+            </a:r>
+          </a:p>
+        </p:txBody>
+      </p:sp>
+      <p:sp>
+        <p:nvSpPr>
+          <p:cNvPr id="22" name="TextBox 21"/>
+          <p:cNvSpPr txBox="1"/>
+          <p:nvPr/>
+        </p:nvSpPr>
+        <p:spPr>
+          <a:xfrm>
+            <a:off x="6553047" y="4732020"/>
+            <a:ext cx="4861407" cy="1211580"/>
+          </a:xfrm>
+          <a:prstGeom prst="rect">
+            <a:avLst/>
+          </a:prstGeom>
+          <a:noFill/>
+        </p:spPr>
+        <p:txBody>
+          <a:bodyPr wrap="square" lIns="0" rIns="0" tIns="0" bIns="0" anchor="t">
+            <a:spAutoFit/>
+          </a:bodyPr>
+          <a:lstStyle/>
+          <a:p>
+            <a:pPr algn="l">
+              <a:lnSpc>
+                <a:spcPct val="120000"/>
+              </a:lnSpc>
+            </a:pPr>
+            <a:r>
+              <a:rPr sz="1500" b="0">
+                <a:solidFill>
+                  <a:srgbClr val="333333"/>
+                </a:solidFill>
+                <a:latin typeface="Arial"/>
+              </a:rPr>
+              <a:t>Raise approved transfers in the ERP, retrain on a schedule, and learn from planner rejections.</a:t>
+            </a:r>
+          </a:p>
+        </p:txBody>
+      </p:sp>
+    </p:spTree>
+  </p:cSld>
+  <p:clrMapOvr>
+    <a:masterClrMapping/>
+  </p:clrMapOvr>
+</p:sld>
+</file>
+
+<file path=ppt/slides/slide11.xml><?xml version="1.0" encoding="utf-8"?>
+<p:sld xmlns:a="http://schemas.openxmlformats.org/drawingml/2006/main" xmlns:p="http://schemas.openxmlformats.org/presentationml/2006/main" xmlns:r="http://schemas.openxmlformats.org/officeDocument/2006/relationships">
+  <p:cSld>
+    <p:spTree>
+      <p:nvGrpSpPr>
+        <p:cNvPr id="1" name=""/>
+        <p:cNvGrpSpPr/>
+        <p:nvPr/>
+      </p:nvGrpSpPr>
+      <p:grpSpPr/>
+      <p:sp>
+        <p:nvSpPr>
+          <p:cNvPr id="2" name="Rectangle 1"/>
+          <p:cNvSpPr/>
+          <p:nvPr/>
+        </p:nvSpPr>
+        <p:spPr>
+          <a:xfrm>
+            <a:off x="548640" y="384048"/>
+            <a:ext cx="822960" cy="82296"/>
+          </a:xfrm>
+          <a:prstGeom prst="rect">
+            <a:avLst/>
+          </a:prstGeom>
+          <a:solidFill>
+            <a:srgbClr val="FFB502"/>
+          </a:solidFill>
+          <a:ln>
+            <a:noFill/>
+          </a:ln>
+          <a:effectLst/>
+        </p:spPr>
+        <p:txBody>
+          <a:bodyPr rtlCol="0" anchor="ctr"/>
+          <a:lstStyle/>
+          <a:p>
+            <a:pPr algn="ctr"/>
+          </a:p>
+        </p:txBody>
+      </p:sp>
+      <p:sp>
+        <p:nvSpPr>
+          <p:cNvPr id="3" name="TextBox 2"/>
+          <p:cNvSpPr txBox="1"/>
+          <p:nvPr/>
+        </p:nvSpPr>
+        <p:spPr>
+          <a:xfrm>
+            <a:off x="548640" y="566928"/>
+            <a:ext cx="11094415" cy="914400"/>
+          </a:xfrm>
+          <a:prstGeom prst="rect">
+            <a:avLst/>
+          </a:prstGeom>
+          <a:noFill/>
+        </p:spPr>
+        <p:txBody>
+          <a:bodyPr wrap="square" lIns="0" rIns="0" tIns="0" bIns="0" anchor="t">
+            <a:spAutoFit/>
+          </a:bodyPr>
+          <a:lstStyle/>
+          <a:p>
+            <a:pPr algn="l">
+              <a:lnSpc>
+                <a:spcPct val="100000"/>
+              </a:lnSpc>
+            </a:pPr>
+            <a:r>
+              <a:rPr sz="2600" b="1">
+                <a:solidFill>
+                  <a:srgbClr val="000000"/>
+                </a:solidFill>
+                <a:latin typeface="Arial"/>
+              </a:rPr>
+              <a:t>Next: a 12-week pilot at 2–3 branches on real ERP and warehouse data</a:t>
+            </a:r>
+          </a:p>
+        </p:txBody>
+      </p:sp>
+      <p:sp>
+        <p:nvSpPr>
+          <p:cNvPr id="4" name="Rectangle 3"/>
+          <p:cNvSpPr/>
+          <p:nvPr/>
+        </p:nvSpPr>
+        <p:spPr>
+          <a:xfrm>
+            <a:off x="548640" y="6291072"/>
+            <a:ext cx="11094415" cy="9525"/>
+          </a:xfrm>
+          <a:prstGeom prst="rect">
+            <a:avLst/>
+          </a:prstGeom>
+          <a:solidFill>
+            <a:srgbClr val="D9D9D9"/>
+          </a:solidFill>
+          <a:ln>
+            <a:noFill/>
+          </a:ln>
+          <a:effectLst/>
+        </p:spPr>
+        <p:txBody>
+          <a:bodyPr rtlCol="0" anchor="ctr"/>
+          <a:lstStyle/>
+          <a:p>
+            <a:pPr algn="ctr"/>
+          </a:p>
+        </p:txBody>
+      </p:sp>
+      <p:sp>
+        <p:nvSpPr>
+          <p:cNvPr id="5" name="TextBox 4"/>
+          <p:cNvSpPr txBox="1"/>
+          <p:nvPr/>
+        </p:nvSpPr>
+        <p:spPr>
+          <a:xfrm>
+            <a:off x="548640" y="6400800"/>
+            <a:ext cx="5486400" cy="274320"/>
+          </a:xfrm>
+          <a:prstGeom prst="rect">
+            <a:avLst/>
+          </a:prstGeom>
+          <a:noFill/>
+        </p:spPr>
+        <p:txBody>
+          <a:bodyPr wrap="square" lIns="0" rIns="0" tIns="0" bIns="0" anchor="t">
+            <a:spAutoFit/>
+          </a:bodyPr>
+          <a:lstStyle/>
+          <a:p>
+            <a:pPr algn="l">
+              <a:lnSpc>
+                <a:spcPct val="110000"/>
+              </a:lnSpc>
+            </a:pPr>
+            <a:r>
+              <a:rPr sz="1000" b="0">
+                <a:solidFill>
+                  <a:srgbClr val="6E6E6E"/>
+                </a:solidFill>
+                <a:latin typeface="Arial"/>
+              </a:rPr>
+              <a:t>Synthetic data – for demonstration</a:t>
+            </a:r>
+          </a:p>
+        </p:txBody>
+      </p:sp>
+      <p:sp>
+        <p:nvSpPr>
+          <p:cNvPr id="6" name="TextBox 5"/>
+          <p:cNvSpPr txBox="1"/>
+          <p:nvPr/>
+        </p:nvSpPr>
+        <p:spPr>
+          <a:xfrm>
+            <a:off x="10728655" y="6400800"/>
+            <a:ext cx="914400" cy="274320"/>
+          </a:xfrm>
+          <a:prstGeom prst="rect">
+            <a:avLst/>
+          </a:prstGeom>
+          <a:noFill/>
+        </p:spPr>
+        <p:txBody>
+          <a:bodyPr wrap="square" lIns="0" rIns="0" tIns="0" bIns="0" anchor="t">
+            <a:spAutoFit/>
+          </a:bodyPr>
+          <a:lstStyle/>
+          <a:p>
+            <a:pPr algn="r">
+              <a:lnSpc>
+                <a:spcPct val="110000"/>
+              </a:lnSpc>
+            </a:pPr>
+            <a:r>
+              <a:rPr sz="1000" b="0">
+                <a:solidFill>
+                  <a:srgbClr val="6E6E6E"/>
+                </a:solidFill>
+                <a:latin typeface="Arial"/>
+              </a:rPr>
+              <a:t>11</a:t>
+            </a:r>
+          </a:p>
+        </p:txBody>
+      </p:sp>
+      <p:sp>
+        <p:nvSpPr>
+          <p:cNvPr id="7" name="Rectangle 6"/>
+          <p:cNvSpPr/>
+          <p:nvPr/>
+        </p:nvSpPr>
+        <p:spPr>
+          <a:xfrm>
+            <a:off x="548640" y="1691640"/>
+            <a:ext cx="3423818" cy="82296"/>
+          </a:xfrm>
+          <a:prstGeom prst="rect">
+            <a:avLst/>
+          </a:prstGeom>
+          <a:solidFill>
+            <a:srgbClr val="333333"/>
+          </a:solidFill>
+          <a:ln>
+            <a:noFill/>
+          </a:ln>
+          <a:effectLst/>
+        </p:spPr>
+        <p:txBody>
+          <a:bodyPr rtlCol="0" anchor="ctr"/>
+          <a:lstStyle/>
+          <a:p>
+            <a:pPr algn="ctr"/>
+          </a:p>
+        </p:txBody>
+      </p:sp>
+      <p:sp>
+        <p:nvSpPr>
+          <p:cNvPr id="8" name="TextBox 7"/>
+          <p:cNvSpPr txBox="1"/>
+          <p:nvPr/>
+        </p:nvSpPr>
+        <p:spPr>
+          <a:xfrm>
+            <a:off x="548640" y="1892808"/>
+            <a:ext cx="3423818" cy="320040"/>
+          </a:xfrm>
+          <a:prstGeom prst="rect">
+            <a:avLst/>
+          </a:prstGeom>
+          <a:noFill/>
+        </p:spPr>
+        <p:txBody>
+          <a:bodyPr wrap="square" lIns="0" rIns="0" tIns="0" bIns="0" anchor="t">
+            <a:spAutoFit/>
+          </a:bodyPr>
+          <a:lstStyle/>
+          <a:p>
+            <a:pPr algn="l">
+              <a:lnSpc>
+                <a:spcPct val="110000"/>
+              </a:lnSpc>
+            </a:pPr>
+            <a:r>
+              <a:rPr sz="1200" b="1">
+                <a:solidFill>
+                  <a:srgbClr val="6E6E6E"/>
+                </a:solidFill>
+                <a:latin typeface="Arial"/>
+              </a:rPr>
+              <a:t>Weeks 1–4</a:t>
+            </a:r>
+          </a:p>
+        </p:txBody>
+      </p:sp>
+      <p:sp>
+        <p:nvSpPr>
+          <p:cNvPr id="9" name="TextBox 8"/>
+          <p:cNvSpPr txBox="1"/>
+          <p:nvPr/>
+        </p:nvSpPr>
+        <p:spPr>
+          <a:xfrm>
+            <a:off x="548640" y="2194560"/>
+            <a:ext cx="3423818" cy="457200"/>
+          </a:xfrm>
+          <a:prstGeom prst="rect">
+            <a:avLst/>
+          </a:prstGeom>
+          <a:noFill/>
+        </p:spPr>
+        <p:txBody>
+          <a:bodyPr wrap="square" lIns="0" rIns="0" tIns="0" bIns="0" anchor="t">
+            <a:spAutoFit/>
+          </a:bodyPr>
+          <a:lstStyle/>
+          <a:p>
+            <a:pPr algn="l">
+              <a:lnSpc>
+                <a:spcPct val="110000"/>
+              </a:lnSpc>
+            </a:pPr>
+            <a:r>
+              <a:rPr sz="2000" b="1">
+                <a:solidFill>
+                  <a:srgbClr val="000000"/>
+                </a:solidFill>
+                <a:latin typeface="Arial"/>
+              </a:rPr>
+              <a:t>Connect data</a:t>
+            </a:r>
+          </a:p>
+        </p:txBody>
+      </p:sp>
+      <p:sp>
+        <p:nvSpPr>
+          <p:cNvPr id="10" name="TextBox 9"/>
+          <p:cNvSpPr txBox="1"/>
+          <p:nvPr/>
+        </p:nvSpPr>
+        <p:spPr>
+          <a:xfrm>
+            <a:off x="548640" y="2651760"/>
+            <a:ext cx="3423818" cy="731520"/>
+          </a:xfrm>
+          <a:prstGeom prst="rect">
+            <a:avLst/>
+          </a:prstGeom>
+          <a:noFill/>
+        </p:spPr>
+        <p:txBody>
+          <a:bodyPr wrap="square" lIns="0" rIns="0" tIns="0" bIns="0" anchor="t">
+            <a:spAutoFit/>
+          </a:bodyPr>
+          <a:lstStyle/>
+          <a:p>
+            <a:pPr algn="l">
+              <a:lnSpc>
+                <a:spcPct val="110000"/>
+              </a:lnSpc>
+            </a:pPr>
+            <a:r>
+              <a:rPr sz="1300" b="0">
+                <a:solidFill>
+                  <a:srgbClr val="333333"/>
+                </a:solidFill>
+                <a:latin typeface="Arial"/>
+              </a:rPr>
+              <a:t>7 standard extracts,</a:t>
+            </a:r>
+          </a:p>
+          <a:p>
+            <a:pPr algn="l">
+              <a:lnSpc>
+                <a:spcPct val="110000"/>
+              </a:lnSpc>
+            </a:pPr>
+            <a:r>
+              <a:rPr sz="1300" b="0">
+                <a:solidFill>
+                  <a:srgbClr val="333333"/>
+                </a:solidFill>
+                <a:latin typeface="Arial"/>
+              </a:rPr>
+              <a:t>validated on load</a:t>
+            </a:r>
+          </a:p>
+        </p:txBody>
+      </p:sp>
+      <p:cxnSp>
+        <p:nvCxnSpPr>
+          <p:cNvPr id="11" name="Connector 10"/>
+          <p:cNvCxnSpPr/>
+          <p:nvPr/>
+        </p:nvCxnSpPr>
+        <p:spPr>
+          <a:xfrm>
+            <a:off x="4045610" y="1732788"/>
+            <a:ext cx="265176" cy="0"/>
+          </a:xfrm>
+          <a:prstGeom prst="line">
+            <a:avLst/>
+          </a:prstGeom>
+          <a:ln w="19050">
+            <a:solidFill>
+              <a:srgbClr val="333333"/>
+            </a:solidFill>
+            <a:tailEnd type="triangle" w="med" len="med"/>
+          </a:ln>
+        </p:spPr>
+      </p:cxnSp>
+      <p:sp>
+        <p:nvSpPr>
+          <p:cNvPr id="12" name="Rectangle 11"/>
+          <p:cNvSpPr/>
+          <p:nvPr/>
+        </p:nvSpPr>
+        <p:spPr>
+          <a:xfrm>
+            <a:off x="4383938" y="1691640"/>
+            <a:ext cx="3423818" cy="82296"/>
+          </a:xfrm>
+          <a:prstGeom prst="rect">
+            <a:avLst/>
+          </a:prstGeom>
+          <a:solidFill>
+            <a:srgbClr val="FFB502"/>
+          </a:solidFill>
+          <a:ln>
+            <a:noFill/>
+          </a:ln>
+          <a:effectLst/>
+        </p:spPr>
+        <p:txBody>
+          <a:bodyPr rtlCol="0" anchor="ctr"/>
+          <a:lstStyle/>
+          <a:p>
+            <a:pPr algn="ctr"/>
+          </a:p>
+        </p:txBody>
+      </p:sp>
+      <p:sp>
+        <p:nvSpPr>
+          <p:cNvPr id="13" name="TextBox 12"/>
+          <p:cNvSpPr txBox="1"/>
+          <p:nvPr/>
+        </p:nvSpPr>
+        <p:spPr>
+          <a:xfrm>
+            <a:off x="4383938" y="1892808"/>
+            <a:ext cx="3423818" cy="320040"/>
+          </a:xfrm>
+          <a:prstGeom prst="rect">
+            <a:avLst/>
+          </a:prstGeom>
+          <a:noFill/>
+        </p:spPr>
+        <p:txBody>
+          <a:bodyPr wrap="square" lIns="0" rIns="0" tIns="0" bIns="0" anchor="t">
+            <a:spAutoFit/>
+          </a:bodyPr>
+          <a:lstStyle/>
+          <a:p>
+            <a:pPr algn="l">
+              <a:lnSpc>
+                <a:spcPct val="110000"/>
+              </a:lnSpc>
+            </a:pPr>
+            <a:r>
+              <a:rPr sz="1200" b="1">
+                <a:solidFill>
+                  <a:srgbClr val="6E6E6E"/>
+                </a:solidFill>
+                <a:latin typeface="Arial"/>
+              </a:rPr>
+              <a:t>Weeks 5–10</a:t>
+            </a:r>
+          </a:p>
+        </p:txBody>
+      </p:sp>
+      <p:sp>
+        <p:nvSpPr>
+          <p:cNvPr id="14" name="TextBox 13"/>
+          <p:cNvSpPr txBox="1"/>
+          <p:nvPr/>
+        </p:nvSpPr>
+        <p:spPr>
+          <a:xfrm>
+            <a:off x="4383938" y="2194560"/>
+            <a:ext cx="3423818" cy="457200"/>
+          </a:xfrm>
+          <a:prstGeom prst="rect">
+            <a:avLst/>
+          </a:prstGeom>
+          <a:noFill/>
+        </p:spPr>
+        <p:txBody>
+          <a:bodyPr wrap="square" lIns="0" rIns="0" tIns="0" bIns="0" anchor="t">
+            <a:spAutoFit/>
+          </a:bodyPr>
+          <a:lstStyle/>
+          <a:p>
+            <a:pPr algn="l">
+              <a:lnSpc>
+                <a:spcPct val="110000"/>
+              </a:lnSpc>
+            </a:pPr>
+            <a:r>
+              <a:rPr sz="2000" b="1">
+                <a:solidFill>
+                  <a:srgbClr val="000000"/>
+                </a:solidFill>
+                <a:latin typeface="Arial"/>
+              </a:rPr>
+              <a:t>Shadow pilot</a:t>
+            </a:r>
+          </a:p>
+        </p:txBody>
+      </p:sp>
+      <p:sp>
+        <p:nvSpPr>
+          <p:cNvPr id="15" name="TextBox 14"/>
+          <p:cNvSpPr txBox="1"/>
+          <p:nvPr/>
+        </p:nvSpPr>
+        <p:spPr>
+          <a:xfrm>
+            <a:off x="4383938" y="2651760"/>
+            <a:ext cx="3423818" cy="731520"/>
+          </a:xfrm>
+          <a:prstGeom prst="rect">
+            <a:avLst/>
+          </a:prstGeom>
+          <a:noFill/>
+        </p:spPr>
+        <p:txBody>
+          <a:bodyPr wrap="square" lIns="0" rIns="0" tIns="0" bIns="0" anchor="t">
+            <a:spAutoFit/>
+          </a:bodyPr>
+          <a:lstStyle/>
+          <a:p>
+            <a:pPr algn="l">
+              <a:lnSpc>
+                <a:spcPct val="110000"/>
+              </a:lnSpc>
+            </a:pPr>
+            <a:r>
+              <a:rPr sz="1300" b="0">
+                <a:solidFill>
+                  <a:srgbClr val="333333"/>
+                </a:solidFill>
+                <a:latin typeface="Arial"/>
+              </a:rPr>
+              <a:t>2–3 branches; planners</a:t>
+            </a:r>
+          </a:p>
+          <a:p>
+            <a:pPr algn="l">
+              <a:lnSpc>
+                <a:spcPct val="110000"/>
+              </a:lnSpc>
+            </a:pPr>
+            <a:r>
+              <a:rPr sz="1300" b="0">
+                <a:solidFill>
+                  <a:srgbClr val="333333"/>
+                </a:solidFill>
+                <a:latin typeface="Arial"/>
+              </a:rPr>
+              <a:t>approve or reject</a:t>
+            </a:r>
+          </a:p>
+        </p:txBody>
+      </p:sp>
+      <p:cxnSp>
+        <p:nvCxnSpPr>
+          <p:cNvPr id="16" name="Connector 15"/>
+          <p:cNvCxnSpPr/>
+          <p:nvPr/>
+        </p:nvCxnSpPr>
+        <p:spPr>
+          <a:xfrm>
+            <a:off x="7880908" y="1732788"/>
+            <a:ext cx="265176" cy="0"/>
+          </a:xfrm>
+          <a:prstGeom prst="line">
+            <a:avLst/>
+          </a:prstGeom>
+          <a:ln w="19050">
+            <a:solidFill>
+              <a:srgbClr val="333333"/>
+            </a:solidFill>
+            <a:tailEnd type="triangle" w="med" len="med"/>
+          </a:ln>
+        </p:spPr>
+      </p:cxnSp>
+      <p:sp>
+        <p:nvSpPr>
+          <p:cNvPr id="17" name="Rectangle 16"/>
+          <p:cNvSpPr/>
+          <p:nvPr/>
+        </p:nvSpPr>
+        <p:spPr>
+          <a:xfrm>
+            <a:off x="8219236" y="1691640"/>
+            <a:ext cx="3423818" cy="82296"/>
+          </a:xfrm>
+          <a:prstGeom prst="rect">
+            <a:avLst/>
+          </a:prstGeom>
+          <a:solidFill>
+            <a:srgbClr val="333333"/>
+          </a:solidFill>
+          <a:ln>
+            <a:noFill/>
+          </a:ln>
+          <a:effectLst/>
+        </p:spPr>
+        <p:txBody>
+          <a:bodyPr rtlCol="0" anchor="ctr"/>
+          <a:lstStyle/>
+          <a:p>
+            <a:pPr algn="ctr"/>
+          </a:p>
+        </p:txBody>
+      </p:sp>
+      <p:sp>
+        <p:nvSpPr>
+          <p:cNvPr id="18" name="TextBox 17"/>
+          <p:cNvSpPr txBox="1"/>
+          <p:nvPr/>
+        </p:nvSpPr>
+        <p:spPr>
+          <a:xfrm>
+            <a:off x="8219236" y="1892808"/>
+            <a:ext cx="3423818" cy="320040"/>
+          </a:xfrm>
+          <a:prstGeom prst="rect">
+            <a:avLst/>
+          </a:prstGeom>
+          <a:noFill/>
+        </p:spPr>
+        <p:txBody>
+          <a:bodyPr wrap="square" lIns="0" rIns="0" tIns="0" bIns="0" anchor="t">
+            <a:spAutoFit/>
+          </a:bodyPr>
+          <a:lstStyle/>
+          <a:p>
+            <a:pPr algn="l">
+              <a:lnSpc>
+                <a:spcPct val="110000"/>
+              </a:lnSpc>
+            </a:pPr>
+            <a:r>
+              <a:rPr sz="1200" b="1">
+                <a:solidFill>
+                  <a:srgbClr val="6E6E6E"/>
+                </a:solidFill>
+                <a:latin typeface="Arial"/>
+              </a:rPr>
+              <a:t>Weeks 11–12</a:t>
+            </a:r>
+          </a:p>
+        </p:txBody>
+      </p:sp>
+      <p:sp>
+        <p:nvSpPr>
+          <p:cNvPr id="19" name="TextBox 18"/>
+          <p:cNvSpPr txBox="1"/>
+          <p:nvPr/>
+        </p:nvSpPr>
+        <p:spPr>
+          <a:xfrm>
+            <a:off x="8219236" y="2194560"/>
+            <a:ext cx="3423818" cy="457200"/>
+          </a:xfrm>
+          <a:prstGeom prst="rect">
+            <a:avLst/>
+          </a:prstGeom>
+          <a:noFill/>
+        </p:spPr>
+        <p:txBody>
+          <a:bodyPr wrap="square" lIns="0" rIns="0" tIns="0" bIns="0" anchor="t">
+            <a:spAutoFit/>
+          </a:bodyPr>
+          <a:lstStyle/>
+          <a:p>
+            <a:pPr algn="l">
+              <a:lnSpc>
+                <a:spcPct val="110000"/>
+              </a:lnSpc>
+            </a:pPr>
+            <a:r>
+              <a:rPr sz="2000" b="1">
+                <a:solidFill>
+                  <a:srgbClr val="000000"/>
+                </a:solidFill>
+                <a:latin typeface="Arial"/>
+              </a:rPr>
+              <a:t>Decide</a:t>
+            </a:r>
+          </a:p>
+        </p:txBody>
+      </p:sp>
+      <p:sp>
+        <p:nvSpPr>
+          <p:cNvPr id="20" name="TextBox 19"/>
+          <p:cNvSpPr txBox="1"/>
+          <p:nvPr/>
+        </p:nvSpPr>
+        <p:spPr>
+          <a:xfrm>
+            <a:off x="8219236" y="2651760"/>
+            <a:ext cx="3423818" cy="731520"/>
+          </a:xfrm>
+          <a:prstGeom prst="rect">
+            <a:avLst/>
+          </a:prstGeom>
+          <a:noFill/>
+        </p:spPr>
+        <p:txBody>
+          <a:bodyPr wrap="square" lIns="0" rIns="0" tIns="0" bIns="0" anchor="t">
+            <a:spAutoFit/>
+          </a:bodyPr>
+          <a:lstStyle/>
+          <a:p>
+            <a:pPr algn="l">
+              <a:lnSpc>
+                <a:spcPct val="110000"/>
+              </a:lnSpc>
+            </a:pPr>
+            <a:r>
+              <a:rPr sz="1300" b="0">
+                <a:solidFill>
+                  <a:srgbClr val="333333"/>
+                </a:solidFill>
+                <a:latin typeface="Arial"/>
+              </a:rPr>
+              <a:t>Monitor error and bias;</a:t>
+            </a:r>
+          </a:p>
+          <a:p>
+            <a:pPr algn="l">
+              <a:lnSpc>
+                <a:spcPct val="110000"/>
+              </a:lnSpc>
+            </a:pPr>
+            <a:r>
+              <a:rPr sz="1300" b="0">
+                <a:solidFill>
+                  <a:srgbClr val="333333"/>
+                </a:solidFill>
+                <a:latin typeface="Arial"/>
+              </a:rPr>
+              <a:t>retrain on drift</a:t>
+            </a:r>
+          </a:p>
+        </p:txBody>
+      </p:sp>
+      <p:sp>
+        <p:nvSpPr>
+          <p:cNvPr id="21" name="Rectangle 20"/>
+          <p:cNvSpPr/>
+          <p:nvPr/>
+        </p:nvSpPr>
+        <p:spPr>
+          <a:xfrm>
+            <a:off x="548640" y="3886200"/>
+            <a:ext cx="11094415" cy="9525"/>
+          </a:xfrm>
+          <a:prstGeom prst="rect">
+            <a:avLst/>
+          </a:prstGeom>
+          <a:solidFill>
+            <a:srgbClr val="D9D9D9"/>
+          </a:solidFill>
+          <a:ln>
+            <a:noFill/>
+          </a:ln>
+          <a:effectLst/>
+        </p:spPr>
+        <p:txBody>
+          <a:bodyPr rtlCol="0" anchor="ctr"/>
+          <a:lstStyle/>
+          <a:p>
+            <a:pPr algn="ctr"/>
+          </a:p>
+        </p:txBody>
+      </p:sp>
+      <p:sp>
+        <p:nvSpPr>
+          <p:cNvPr id="22" name="TextBox 21"/>
+          <p:cNvSpPr txBox="1"/>
+          <p:nvPr/>
+        </p:nvSpPr>
+        <p:spPr>
+          <a:xfrm>
+            <a:off x="548640" y="4069080"/>
+            <a:ext cx="2743200" cy="320040"/>
+          </a:xfrm>
+          <a:prstGeom prst="rect">
+            <a:avLst/>
+          </a:prstGeom>
+          <a:noFill/>
+        </p:spPr>
+        <p:txBody>
+          <a:bodyPr wrap="square" lIns="0" rIns="0" tIns="0" bIns="0" anchor="t">
+            <a:spAutoFit/>
+          </a:bodyPr>
+          <a:lstStyle/>
+          <a:p>
+            <a:pPr algn="l">
+              <a:lnSpc>
+                <a:spcPct val="110000"/>
+              </a:lnSpc>
+            </a:pPr>
+            <a:r>
+              <a:rPr sz="1400" b="1">
+                <a:solidFill>
+                  <a:srgbClr val="000000"/>
+                </a:solidFill>
+                <a:latin typeface="Arial"/>
+              </a:rPr>
+              <a:t>Limitations</a:t>
+            </a:r>
+          </a:p>
+        </p:txBody>
+      </p:sp>
+      <p:sp>
+        <p:nvSpPr>
+          <p:cNvPr id="23" name="Rectangle 22"/>
+          <p:cNvSpPr/>
+          <p:nvPr/>
+        </p:nvSpPr>
+        <p:spPr>
+          <a:xfrm>
+            <a:off x="548640" y="4480560"/>
+            <a:ext cx="2567863" cy="685800"/>
+          </a:xfrm>
+          <a:prstGeom prst="rect">
+            <a:avLst/>
+          </a:prstGeom>
+          <a:solidFill>
+            <a:srgbClr val="F2F2F2"/>
+          </a:solidFill>
+          <a:ln w="12700">
+            <a:solidFill>
+              <a:srgbClr val="D9D9D9"/>
+            </a:solidFill>
+          </a:ln>
+          <a:effectLst/>
+        </p:spPr>
+        <p:txBody>
+          <a:bodyPr rtlCol="0" anchor="ctr" lIns="54864" rIns="54864" wrap="square"/>
+          <a:lstStyle/>
+          <a:p>
+            <a:pPr algn="ctr"/>
+            <a:r>
+              <a:rPr sz="1300" b="0">
+                <a:solidFill>
+                  <a:srgbClr val="000000"/>
+                </a:solidFill>
+                <a:latin typeface="Arial"/>
+              </a:rPr>
+              <a:t>Synthetic data so far</a:t>
+            </a:r>
+          </a:p>
+        </p:txBody>
+      </p:sp>
+      <p:sp>
+        <p:nvSpPr>
+          <p:cNvPr id="24" name="Rectangle 23"/>
+          <p:cNvSpPr/>
+          <p:nvPr/>
+        </p:nvSpPr>
+        <p:spPr>
+          <a:xfrm>
+            <a:off x="3390823" y="4480560"/>
+            <a:ext cx="2567863" cy="685800"/>
+          </a:xfrm>
+          <a:prstGeom prst="rect">
+            <a:avLst/>
+          </a:prstGeom>
+          <a:solidFill>
+            <a:srgbClr val="F2F2F2"/>
+          </a:solidFill>
+          <a:ln w="12700">
+            <a:solidFill>
+              <a:srgbClr val="D9D9D9"/>
+            </a:solidFill>
+          </a:ln>
+          <a:effectLst/>
+        </p:spPr>
+        <p:txBody>
+          <a:bodyPr rtlCol="0" anchor="ctr" lIns="54864" rIns="54864" wrap="square"/>
+          <a:lstStyle/>
+          <a:p>
+            <a:pPr algn="ctr"/>
+            <a:r>
+              <a:rPr sz="1300" b="0">
+                <a:solidFill>
+                  <a:srgbClr val="000000"/>
+                </a:solidFill>
+                <a:latin typeface="Arial"/>
+              </a:rPr>
+              <a:t>Plans one replenishment cycle</a:t>
+            </a:r>
+          </a:p>
+        </p:txBody>
+      </p:sp>
+      <p:sp>
+        <p:nvSpPr>
+          <p:cNvPr id="25" name="Rectangle 24"/>
+          <p:cNvSpPr/>
+          <p:nvPr/>
+        </p:nvSpPr>
+        <p:spPr>
+          <a:xfrm>
+            <a:off x="6233006" y="4480560"/>
+            <a:ext cx="2567863" cy="685800"/>
+          </a:xfrm>
+          <a:prstGeom prst="rect">
+            <a:avLst/>
+          </a:prstGeom>
+          <a:solidFill>
+            <a:srgbClr val="F2F2F2"/>
+          </a:solidFill>
+          <a:ln w="12700">
+            <a:solidFill>
+              <a:srgbClr val="D9D9D9"/>
+            </a:solidFill>
+          </a:ln>
+          <a:effectLst/>
+        </p:spPr>
+        <p:txBody>
+          <a:bodyPr rtlCol="0" anchor="ctr" lIns="54864" rIns="54864" wrap="square"/>
+          <a:lstStyle/>
+          <a:p>
+            <a:pPr algn="ctr"/>
+            <a:r>
+              <a:rPr sz="1300" b="0">
+                <a:solidFill>
+                  <a:srgbClr val="000000"/>
+                </a:solidFill>
+                <a:latin typeface="Arial"/>
+              </a:rPr>
+              <a:t>Normal error model for safety stock</a:t>
+            </a:r>
+          </a:p>
+        </p:txBody>
+      </p:sp>
+      <p:sp>
+        <p:nvSpPr>
+          <p:cNvPr id="26" name="Rectangle 25"/>
+          <p:cNvSpPr/>
+          <p:nvPr/>
+        </p:nvSpPr>
+        <p:spPr>
+          <a:xfrm>
+            <a:off x="9075189" y="4480560"/>
+            <a:ext cx="2567863" cy="685800"/>
+          </a:xfrm>
+          <a:prstGeom prst="rect">
+            <a:avLst/>
+          </a:prstGeom>
+          <a:solidFill>
+            <a:srgbClr val="F2F2F2"/>
+          </a:solidFill>
+          <a:ln w="12700">
+            <a:solidFill>
+              <a:srgbClr val="D9D9D9"/>
+            </a:solidFill>
+          </a:ln>
+          <a:effectLst/>
+        </p:spPr>
+        <p:txBody>
+          <a:bodyPr rtlCol="0" anchor="ctr" lIns="54864" rIns="54864" wrap="square"/>
+          <a:lstStyle/>
+          <a:p>
+            <a:pPr algn="ctr"/>
+            <a:r>
+              <a:rPr sz="1300" b="0">
+                <a:solidFill>
+                  <a:srgbClr val="000000"/>
+                </a:solidFill>
+                <a:latin typeface="Arial"/>
+              </a:rPr>
+              <a:t>Costs need finance approval</a:t>
+            </a:r>
+          </a:p>
+        </p:txBody>
+      </p:sp>
+      <p:sp>
+        <p:nvSpPr>
+          <p:cNvPr id="27" name="TextBox 26"/>
+          <p:cNvSpPr txBox="1"/>
+          <p:nvPr/>
+        </p:nvSpPr>
+        <p:spPr>
+          <a:xfrm>
+            <a:off x="548640" y="5486400"/>
+            <a:ext cx="11094415" cy="548640"/>
+          </a:xfrm>
+          <a:prstGeom prst="rect">
+            <a:avLst/>
+          </a:prstGeom>
+          <a:noFill/>
+        </p:spPr>
+        <p:txBody>
+          <a:bodyPr wrap="square" lIns="0" rIns="0" tIns="0" bIns="0" anchor="t">
+            <a:spAutoFit/>
+          </a:bodyPr>
+          <a:lstStyle/>
+          <a:p>
+            <a:pPr algn="ctr">
+              <a:lnSpc>
+                <a:spcPct val="110000"/>
+              </a:lnSpc>
+            </a:pPr>
+            <a:r>
+              <a:rPr sz="1600" b="1">
+                <a:solidFill>
+                  <a:srgbClr val="000000"/>
+                </a:solidFill>
+                <a:latin typeface="Arial"/>
+              </a:rPr>
+              <a:t>Right product, right branch: surgeons don't wait, so patients don't either.</a:t>
+            </a:r>
+          </a:p>
+        </p:txBody>
+      </p:sp>
+    </p:spTree>
+  </p:cSld>
+  <p:clrMapOvr>
+    <a:masterClrMapping/>
+  </p:clrMapOvr>
+</p:sld>
+</file>
+
 <file path=ppt/slides/slide2.xml><?xml version="1.0" encoding="utf-8"?>
 <p:sld xmlns:a="http://schemas.openxmlformats.org/drawingml/2006/main" xmlns:p="http://schemas.openxmlformats.org/presentationml/2006/main" xmlns:r="http://schemas.openxmlformats.org/officeDocument/2006/relationships">
   <p:cSld>
@@ -10940,7 +12972,7 @@
                 </a:solidFill>
                 <a:latin typeface="Arial"/>
               </a:rPr>
-              <a:t>Next: a 12-week pilot at 2–3 branches on real ERP and warehouse data</a:t>
+              <a:t>Four challenges shaped the design, and each one left the tool stronger</a:t>
             </a:r>
           </a:p>
         </p:txBody>
@@ -11061,8 +13093,38 @@
         </p:nvSpPr>
         <p:spPr>
           <a:xfrm>
-            <a:off x="548640" y="1691640"/>
-            <a:ext cx="3423818" cy="82296"/>
+            <a:off x="548640" y="1645920"/>
+            <a:ext cx="5364327" cy="2080260"/>
+          </a:xfrm>
+          <a:prstGeom prst="rect">
+            <a:avLst/>
+          </a:prstGeom>
+          <a:solidFill>
+            <a:srgbClr val="F2F2F2"/>
+          </a:solidFill>
+          <a:ln>
+            <a:noFill/>
+          </a:ln>
+          <a:effectLst/>
+        </p:spPr>
+        <p:txBody>
+          <a:bodyPr rtlCol="0" anchor="ctr"/>
+          <a:lstStyle/>
+          <a:p>
+            <a:pPr algn="ctr"/>
+          </a:p>
+        </p:txBody>
+      </p:sp>
+      <p:sp>
+        <p:nvSpPr>
+          <p:cNvPr id="8" name="Rectangle 7"/>
+          <p:cNvSpPr/>
+          <p:nvPr/>
+        </p:nvSpPr>
+        <p:spPr>
+          <a:xfrm>
+            <a:off x="548640" y="1645920"/>
+            <a:ext cx="82296" cy="2080260"/>
           </a:xfrm>
           <a:prstGeom prst="rect">
             <a:avLst/>
@@ -11085,14 +13147,14 @@
       </p:sp>
       <p:sp>
         <p:nvSpPr>
-          <p:cNvPr id="8" name="TextBox 7"/>
+          <p:cNvPr id="9" name="TextBox 8"/>
           <p:cNvSpPr txBox="1"/>
           <p:nvPr/>
         </p:nvSpPr>
         <p:spPr>
           <a:xfrm>
-            <a:off x="548640" y="1892808"/>
-            <a:ext cx="3423818" cy="320040"/>
+            <a:off x="822960" y="1828800"/>
+            <a:ext cx="4861407" cy="457200"/>
           </a:xfrm>
           <a:prstGeom prst="rect">
             <a:avLst/>
@@ -11111,27 +13173,27 @@
               </a:lnSpc>
             </a:pPr>
             <a:r>
-              <a:rPr sz="1200" b="1">
-                <a:solidFill>
-                  <a:srgbClr val="6E6E6E"/>
+              <a:rPr sz="1900" b="1">
+                <a:solidFill>
+                  <a:srgbClr val="000000"/>
                 </a:solidFill>
                 <a:latin typeface="Arial"/>
               </a:rPr>
-              <a:t>Weeks 1–4</a:t>
-            </a:r>
-          </a:p>
-        </p:txBody>
-      </p:sp>
-      <p:sp>
-        <p:nvSpPr>
-          <p:cNvPr id="9" name="TextBox 8"/>
+              <a:t>Stock-out days hide real demand</a:t>
+            </a:r>
+          </a:p>
+        </p:txBody>
+      </p:sp>
+      <p:sp>
+        <p:nvSpPr>
+          <p:cNvPr id="10" name="TextBox 9"/>
           <p:cNvSpPr txBox="1"/>
           <p:nvPr/>
         </p:nvSpPr>
         <p:spPr>
           <a:xfrm>
-            <a:off x="548640" y="2194560"/>
-            <a:ext cx="3423818" cy="457200"/>
+            <a:off x="822960" y="2377440"/>
+            <a:ext cx="4861407" cy="1211580"/>
           </a:xfrm>
           <a:prstGeom prst="rect">
             <a:avLst/>
@@ -11146,98 +13208,76 @@
           <a:p>
             <a:pPr algn="l">
               <a:lnSpc>
-                <a:spcPct val="110000"/>
+                <a:spcPct val="120000"/>
               </a:lnSpc>
             </a:pPr>
             <a:r>
-              <a:rPr sz="2000" b="1">
-                <a:solidFill>
-                  <a:srgbClr val="000000"/>
+              <a:rPr sz="1500" b="0">
+                <a:solidFill>
+                  <a:srgbClr val="333333"/>
                 </a:solidFill>
                 <a:latin typeface="Arial"/>
               </a:rPr>
-              <a:t>Connect data</a:t>
-            </a:r>
-          </a:p>
-        </p:txBody>
-      </p:sp>
-      <p:sp>
-        <p:nvSpPr>
-          <p:cNvPr id="10" name="TextBox 9"/>
-          <p:cNvSpPr txBox="1"/>
-          <p:nvPr/>
-        </p:nvSpPr>
-        <p:spPr>
-          <a:xfrm>
-            <a:off x="548640" y="2651760"/>
-            <a:ext cx="3423818" cy="731520"/>
-          </a:xfrm>
-          <a:prstGeom prst="rect">
-            <a:avLst/>
-          </a:prstGeom>
-          <a:noFill/>
-        </p:spPr>
-        <p:txBody>
-          <a:bodyPr wrap="square" lIns="0" rIns="0" tIns="0" bIns="0" anchor="t">
-            <a:spAutoFit/>
-          </a:bodyPr>
-          <a:lstStyle/>
+              <a:t>Empty shelves on 5.8% of branch-product days record zero sales, not zero demand.</a:t>
+            </a:r>
+          </a:p>
           <a:p>
             <a:pPr algn="l">
               <a:lnSpc>
-                <a:spcPct val="110000"/>
+                <a:spcPct val="120000"/>
               </a:lnSpc>
             </a:pPr>
             <a:r>
-              <a:rPr sz="1300" b="0">
+              <a:rPr sz="1500" b="1">
                 <a:solidFill>
                   <a:srgbClr val="333333"/>
                 </a:solidFill>
                 <a:latin typeface="Arial"/>
               </a:rPr>
-              <a:t>7 standard extracts,</a:t>
-            </a:r>
-          </a:p>
-          <a:p>
-            <a:pPr algn="l">
-              <a:lnSpc>
-                <a:spcPct val="110000"/>
-              </a:lnSpc>
-            </a:pPr>
-            <a:r>
-              <a:rPr sz="1300" b="0">
+              <a:t>Fix: </a:t>
+            </a:r>
+            <a:r>
+              <a:rPr sz="1500" b="0">
                 <a:solidFill>
                   <a:srgbClr val="333333"/>
                 </a:solidFill>
                 <a:latin typeface="Arial"/>
               </a:rPr>
-              <a:t>validated on load</a:t>
-            </a:r>
-          </a:p>
-        </p:txBody>
-      </p:sp>
-      <p:cxnSp>
-        <p:nvCxnSpPr>
-          <p:cNvPr id="11" name="Connector 10"/>
-          <p:cNvCxnSpPr/>
-          <p:nvPr/>
-        </p:nvCxnSpPr>
-        <p:spPr>
-          <a:xfrm>
-            <a:off x="4045610" y="1732788"/>
-            <a:ext cx="265176" cy="0"/>
-          </a:xfrm>
-          <a:prstGeom prst="line">
-            <a:avLst/>
-          </a:prstGeom>
-          <a:ln w="19050">
-            <a:solidFill>
-              <a:srgbClr val="333333"/>
-            </a:solidFill>
-            <a:tailEnd type="triangle" w="med" len="med"/>
+              <a:t>flagged and excluded those days from training and scoring.</a:t>
+            </a:r>
+          </a:p>
+        </p:txBody>
+      </p:sp>
+      <p:sp>
+        <p:nvSpPr>
+          <p:cNvPr id="11" name="Rectangle 10"/>
+          <p:cNvSpPr/>
+          <p:nvPr/>
+        </p:nvSpPr>
+        <p:spPr>
+          <a:xfrm>
+            <a:off x="6278727" y="1645920"/>
+            <a:ext cx="5364327" cy="2080260"/>
+          </a:xfrm>
+          <a:prstGeom prst="rect">
+            <a:avLst/>
+          </a:prstGeom>
+          <a:solidFill>
+            <a:srgbClr val="F2F2F2"/>
+          </a:solidFill>
+          <a:ln>
+            <a:noFill/>
           </a:ln>
-        </p:spPr>
-      </p:cxnSp>
+          <a:effectLst/>
+        </p:spPr>
+        <p:txBody>
+          <a:bodyPr rtlCol="0" anchor="ctr"/>
+          <a:lstStyle/>
+          <a:p>
+            <a:pPr algn="ctr"/>
+          </a:p>
+        </p:txBody>
+      </p:sp>
       <p:sp>
         <p:nvSpPr>
           <p:cNvPr id="12" name="Rectangle 11"/>
@@ -11246,8 +13286,8 @@
         </p:nvSpPr>
         <p:spPr>
           <a:xfrm>
-            <a:off x="4383938" y="1691640"/>
-            <a:ext cx="3423818" cy="82296"/>
+            <a:off x="6278727" y="1645920"/>
+            <a:ext cx="82296" cy="2080260"/>
           </a:xfrm>
           <a:prstGeom prst="rect">
             <a:avLst/>
@@ -11276,8 +13316,8 @@
         </p:nvSpPr>
         <p:spPr>
           <a:xfrm>
-            <a:off x="4383938" y="1892808"/>
-            <a:ext cx="3423818" cy="320040"/>
+            <a:off x="6553047" y="1828800"/>
+            <a:ext cx="4861407" cy="457200"/>
           </a:xfrm>
           <a:prstGeom prst="rect">
             <a:avLst/>
@@ -11296,13 +13336,13 @@
               </a:lnSpc>
             </a:pPr>
             <a:r>
-              <a:rPr sz="1200" b="1">
-                <a:solidFill>
-                  <a:srgbClr val="6E6E6E"/>
+              <a:rPr sz="1900" b="1">
+                <a:solidFill>
+                  <a:srgbClr val="000000"/>
                 </a:solidFill>
                 <a:latin typeface="Arial"/>
               </a:rPr>
-              <a:t>Weeks 5–10</a:t>
+              <a:t>The forecast ran 2.6% low at 10× scale</a:t>
             </a:r>
           </a:p>
         </p:txBody>
@@ -11315,8 +13355,8 @@
         </p:nvSpPr>
         <p:spPr>
           <a:xfrm>
-            <a:off x="4383938" y="2194560"/>
-            <a:ext cx="3423818" cy="457200"/>
+            <a:off x="6553047" y="2377440"/>
+            <a:ext cx="4861407" cy="1211580"/>
           </a:xfrm>
           <a:prstGeom prst="rect">
             <a:avLst/>
@@ -11331,108 +13371,86 @@
           <a:p>
             <a:pPr algn="l">
               <a:lnSpc>
-                <a:spcPct val="110000"/>
+                <a:spcPct val="120000"/>
               </a:lnSpc>
             </a:pPr>
             <a:r>
-              <a:rPr sz="2000" b="1">
-                <a:solidFill>
-                  <a:srgbClr val="000000"/>
+              <a:rPr sz="1500" b="0">
+                <a:solidFill>
+                  <a:srgbClr val="333333"/>
                 </a:solidFill>
                 <a:latin typeface="Arial"/>
               </a:rPr>
-              <a:t>Shadow pilot</a:t>
-            </a:r>
-          </a:p>
-        </p:txBody>
-      </p:sp>
-      <p:sp>
-        <p:nvSpPr>
-          <p:cNvPr id="15" name="TextBox 14"/>
-          <p:cNvSpPr txBox="1"/>
-          <p:nvPr/>
-        </p:nvSpPr>
-        <p:spPr>
-          <a:xfrm>
-            <a:off x="4383938" y="2651760"/>
-            <a:ext cx="3423818" cy="731520"/>
-          </a:xfrm>
-          <a:prstGeom prst="rect">
-            <a:avLst/>
-          </a:prstGeom>
-          <a:noFill/>
-        </p:spPr>
-        <p:txBody>
-          <a:bodyPr wrap="square" lIns="0" rIns="0" tIns="0" bIns="0" anchor="t">
-            <a:spAutoFit/>
-          </a:bodyPr>
-          <a:lstStyle/>
+              <a:t>My first theory was wrong; an experiment ruled it out before I built anything.</a:t>
+            </a:r>
+          </a:p>
           <a:p>
             <a:pPr algn="l">
               <a:lnSpc>
-                <a:spcPct val="110000"/>
+                <a:spcPct val="120000"/>
               </a:lnSpc>
             </a:pPr>
             <a:r>
-              <a:rPr sz="1300" b="0">
+              <a:rPr sz="1500" b="1">
                 <a:solidFill>
                   <a:srgbClr val="333333"/>
                 </a:solidFill>
                 <a:latin typeface="Arial"/>
               </a:rPr>
-              <a:t>2–3 branches; planners</a:t>
-            </a:r>
-          </a:p>
-          <a:p>
-            <a:pPr algn="l">
-              <a:lnSpc>
-                <a:spcPct val="110000"/>
-              </a:lnSpc>
-            </a:pPr>
-            <a:r>
-              <a:rPr sz="1300" b="0">
+              <a:t>Fix: </a:t>
+            </a:r>
+            <a:r>
+              <a:rPr sz="1500" b="0">
                 <a:solidFill>
                   <a:srgbClr val="333333"/>
                 </a:solidFill>
                 <a:latin typeface="Arial"/>
               </a:rPr>
-              <a:t>approve or reject</a:t>
-            </a:r>
-          </a:p>
-        </p:txBody>
-      </p:sp>
-      <p:cxnSp>
-        <p:nvCxnSpPr>
-          <p:cNvPr id="16" name="Connector 15"/>
-          <p:cNvCxnSpPr/>
-          <p:nvPr/>
-        </p:nvCxnSpPr>
-        <p:spPr>
-          <a:xfrm>
-            <a:off x="7880908" y="1732788"/>
-            <a:ext cx="265176" cy="0"/>
-          </a:xfrm>
-          <a:prstGeom prst="line">
-            <a:avLst/>
-          </a:prstGeom>
-          <a:ln w="19050">
-            <a:solidFill>
-              <a:srgbClr val="333333"/>
-            </a:solidFill>
-            <a:tailEnd type="triangle" w="med" len="med"/>
+              <a:t>per-segment correction from past months only. Bias −2.6% → −0.8%.</a:t>
+            </a:r>
+          </a:p>
+        </p:txBody>
+      </p:sp>
+      <p:sp>
+        <p:nvSpPr>
+          <p:cNvPr id="15" name="Rectangle 14"/>
+          <p:cNvSpPr/>
+          <p:nvPr/>
+        </p:nvSpPr>
+        <p:spPr>
+          <a:xfrm>
+            <a:off x="548640" y="4000500"/>
+            <a:ext cx="5364327" cy="2080260"/>
+          </a:xfrm>
+          <a:prstGeom prst="rect">
+            <a:avLst/>
+          </a:prstGeom>
+          <a:solidFill>
+            <a:srgbClr val="F2F2F2"/>
+          </a:solidFill>
+          <a:ln>
+            <a:noFill/>
           </a:ln>
-        </p:spPr>
-      </p:cxnSp>
-      <p:sp>
-        <p:nvSpPr>
-          <p:cNvPr id="17" name="Rectangle 16"/>
+          <a:effectLst/>
+        </p:spPr>
+        <p:txBody>
+          <a:bodyPr rtlCol="0" anchor="ctr"/>
+          <a:lstStyle/>
+          <a:p>
+            <a:pPr algn="ctr"/>
+          </a:p>
+        </p:txBody>
+      </p:sp>
+      <p:sp>
+        <p:nvSpPr>
+          <p:cNvPr id="16" name="Rectangle 15"/>
           <p:cNvSpPr/>
           <p:nvPr/>
         </p:nvSpPr>
         <p:spPr>
           <a:xfrm>
-            <a:off x="8219236" y="1691640"/>
-            <a:ext cx="3423818" cy="82296"/>
+            <a:off x="548640" y="4000500"/>
+            <a:ext cx="82296" cy="2080260"/>
           </a:xfrm>
           <a:prstGeom prst="rect">
             <a:avLst/>
@@ -11455,14 +13473,14 @@
       </p:sp>
       <p:sp>
         <p:nvSpPr>
-          <p:cNvPr id="18" name="TextBox 17"/>
+          <p:cNvPr id="17" name="TextBox 16"/>
           <p:cNvSpPr txBox="1"/>
           <p:nvPr/>
         </p:nvSpPr>
         <p:spPr>
           <a:xfrm>
-            <a:off x="8219236" y="1892808"/>
-            <a:ext cx="3423818" cy="320040"/>
+            <a:off x="822960" y="4183380"/>
+            <a:ext cx="4861407" cy="457200"/>
           </a:xfrm>
           <a:prstGeom prst="rect">
             <a:avLst/>
@@ -11481,27 +13499,151 @@
               </a:lnSpc>
             </a:pPr>
             <a:r>
-              <a:rPr sz="1200" b="1">
-                <a:solidFill>
-                  <a:srgbClr val="6E6E6E"/>
+              <a:rPr sz="1900" b="1">
+                <a:solidFill>
+                  <a:srgbClr val="000000"/>
                 </a:solidFill>
                 <a:latin typeface="Arial"/>
               </a:rPr>
-              <a:t>Weeks 11–12</a:t>
-            </a:r>
-          </a:p>
-        </p:txBody>
-      </p:sp>
-      <p:sp>
-        <p:nvSpPr>
-          <p:cNvPr id="19" name="TextBox 18"/>
+              <a:t>The optimization grows fast with scale</a:t>
+            </a:r>
+          </a:p>
+        </p:txBody>
+      </p:sp>
+      <p:sp>
+        <p:nvSpPr>
+          <p:cNvPr id="18" name="TextBox 17"/>
           <p:cNvSpPr txBox="1"/>
           <p:nvPr/>
         </p:nvSpPr>
         <p:spPr>
           <a:xfrm>
-            <a:off x="8219236" y="2194560"/>
-            <a:ext cx="3423818" cy="457200"/>
+            <a:off x="822960" y="4732020"/>
+            <a:ext cx="4861407" cy="1211580"/>
+          </a:xfrm>
+          <a:prstGeom prst="rect">
+            <a:avLst/>
+          </a:prstGeom>
+          <a:noFill/>
+        </p:spPr>
+        <p:txBody>
+          <a:bodyPr wrap="square" lIns="0" rIns="0" tIns="0" bIns="0" anchor="t">
+            <a:spAutoFit/>
+          </a:bodyPr>
+          <a:lstStyle/>
+          <a:p>
+            <a:pPr algn="l">
+              <a:lnSpc>
+                <a:spcPct val="120000"/>
+              </a:lnSpc>
+            </a:pPr>
+            <a:r>
+              <a:rPr sz="1500" b="0">
+                <a:solidFill>
+                  <a:srgbClr val="333333"/>
+                </a:solidFill>
+                <a:latin typeface="Arial"/>
+              </a:rPr>
+              <a:t>Every product can move between every pair of branches.</a:t>
+            </a:r>
+          </a:p>
+          <a:p>
+            <a:pPr algn="l">
+              <a:lnSpc>
+                <a:spcPct val="120000"/>
+              </a:lnSpc>
+            </a:pPr>
+            <a:r>
+              <a:rPr sz="1500" b="1">
+                <a:solidFill>
+                  <a:srgbClr val="333333"/>
+                </a:solidFill>
+                <a:latin typeface="Arial"/>
+              </a:rPr>
+              <a:t>Fix: </a:t>
+            </a:r>
+            <a:r>
+              <a:rPr sz="1500" b="0">
+                <a:solidFill>
+                  <a:srgbClr val="333333"/>
+                </a:solidFill>
+                <a:latin typeface="Arial"/>
+              </a:rPr>
+              <a:t>pruned routes that can't pay off; parallel product batches. 10×: 160 batches in ~15 min.</a:t>
+            </a:r>
+          </a:p>
+        </p:txBody>
+      </p:sp>
+      <p:sp>
+        <p:nvSpPr>
+          <p:cNvPr id="19" name="Rectangle 18"/>
+          <p:cNvSpPr/>
+          <p:nvPr/>
+        </p:nvSpPr>
+        <p:spPr>
+          <a:xfrm>
+            <a:off x="6278727" y="4000500"/>
+            <a:ext cx="5364327" cy="2080260"/>
+          </a:xfrm>
+          <a:prstGeom prst="rect">
+            <a:avLst/>
+          </a:prstGeom>
+          <a:solidFill>
+            <a:srgbClr val="F2F2F2"/>
+          </a:solidFill>
+          <a:ln>
+            <a:noFill/>
+          </a:ln>
+          <a:effectLst/>
+        </p:spPr>
+        <p:txBody>
+          <a:bodyPr rtlCol="0" anchor="ctr"/>
+          <a:lstStyle/>
+          <a:p>
+            <a:pPr algn="ctr"/>
+          </a:p>
+        </p:txBody>
+      </p:sp>
+      <p:sp>
+        <p:nvSpPr>
+          <p:cNvPr id="20" name="Rectangle 19"/>
+          <p:cNvSpPr/>
+          <p:nvPr/>
+        </p:nvSpPr>
+        <p:spPr>
+          <a:xfrm>
+            <a:off x="6278727" y="4000500"/>
+            <a:ext cx="82296" cy="2080260"/>
+          </a:xfrm>
+          <a:prstGeom prst="rect">
+            <a:avLst/>
+          </a:prstGeom>
+          <a:solidFill>
+            <a:srgbClr val="FFB502"/>
+          </a:solidFill>
+          <a:ln>
+            <a:noFill/>
+          </a:ln>
+          <a:effectLst/>
+        </p:spPr>
+        <p:txBody>
+          <a:bodyPr rtlCol="0" anchor="ctr"/>
+          <a:lstStyle/>
+          <a:p>
+            <a:pPr algn="ctr"/>
+          </a:p>
+        </p:txBody>
+      </p:sp>
+      <p:sp>
+        <p:nvSpPr>
+          <p:cNvPr id="21" name="TextBox 20"/>
+          <p:cNvSpPr txBox="1"/>
+          <p:nvPr/>
+        </p:nvSpPr>
+        <p:spPr>
+          <a:xfrm>
+            <a:off x="6553047" y="4183380"/>
+            <a:ext cx="4861407" cy="457200"/>
           </a:xfrm>
           <a:prstGeom prst="rect">
             <a:avLst/>
@@ -11520,27 +13662,27 @@
               </a:lnSpc>
             </a:pPr>
             <a:r>
-              <a:rPr sz="2000" b="1">
+              <a:rPr sz="1900" b="1">
                 <a:solidFill>
                   <a:srgbClr val="000000"/>
                 </a:solidFill>
                 <a:latin typeface="Arial"/>
               </a:rPr>
-              <a:t>Decide</a:t>
-            </a:r>
-          </a:p>
-        </p:txBody>
-      </p:sp>
-      <p:sp>
-        <p:nvSpPr>
-          <p:cNvPr id="20" name="TextBox 19"/>
+              <a:t>Planners need moves they can check</a:t>
+            </a:r>
+          </a:p>
+        </p:txBody>
+      </p:sp>
+      <p:sp>
+        <p:nvSpPr>
+          <p:cNvPr id="22" name="TextBox 21"/>
           <p:cNvSpPr txBox="1"/>
           <p:nvPr/>
         </p:nvSpPr>
         <p:spPr>
           <a:xfrm>
-            <a:off x="8219236" y="2651760"/>
-            <a:ext cx="3423818" cy="731520"/>
+            <a:off x="6553047" y="4732020"/>
+            <a:ext cx="4861407" cy="1211580"/>
           </a:xfrm>
           <a:prstGeom prst="rect">
             <a:avLst/>
@@ -11555,46 +13697,142 @@
           <a:p>
             <a:pPr algn="l">
               <a:lnSpc>
-                <a:spcPct val="110000"/>
+                <a:spcPct val="120000"/>
               </a:lnSpc>
             </a:pPr>
             <a:r>
-              <a:rPr sz="1300" b="0">
+              <a:rPr sz="1500" b="0">
                 <a:solidFill>
                   <a:srgbClr val="333333"/>
                 </a:solidFill>
                 <a:latin typeface="Arial"/>
               </a:rPr>
-              <a:t>Monitor error and bias;</a:t>
+              <a:t>Accuracy alone doesn't get a transfer approved.</a:t>
             </a:r>
           </a:p>
           <a:p>
             <a:pPr algn="l">
               <a:lnSpc>
-                <a:spcPct val="110000"/>
+                <a:spcPct val="120000"/>
               </a:lnSpc>
             </a:pPr>
             <a:r>
-              <a:rPr sz="1300" b="0">
+              <a:rPr sz="1500" b="1">
                 <a:solidFill>
                   <a:srgbClr val="333333"/>
                 </a:solidFill>
                 <a:latin typeface="Arial"/>
               </a:rPr>
-              <a:t>retrain on drift</a:t>
-            </a:r>
-          </a:p>
-        </p:txBody>
-      </p:sp>
-      <p:sp>
-        <p:nvSpPr>
-          <p:cNvPr id="21" name="Rectangle 20"/>
+              <a:t>Fix: </a:t>
+            </a:r>
+            <a:r>
+              <a:rPr sz="1500" b="0">
+                <a:solidFill>
+                  <a:srgbClr val="333333"/>
+                </a:solidFill>
+                <a:latin typeface="Arial"/>
+              </a:rPr>
+              <a:t>a plain-language reason per move, human approval, and a sensitivity check.</a:t>
+            </a:r>
+          </a:p>
+        </p:txBody>
+      </p:sp>
+    </p:spTree>
+  </p:cSld>
+  <p:clrMapOvr>
+    <a:masterClrMapping/>
+  </p:clrMapOvr>
+</p:sld>
+</file>
+
+<file path=ppt/slides/slide9.xml><?xml version="1.0" encoding="utf-8"?>
+<p:sld xmlns:a="http://schemas.openxmlformats.org/drawingml/2006/main" xmlns:p="http://schemas.openxmlformats.org/presentationml/2006/main" xmlns:r="http://schemas.openxmlformats.org/officeDocument/2006/relationships">
+  <p:cSld>
+    <p:spTree>
+      <p:nvGrpSpPr>
+        <p:cNvPr id="1" name=""/>
+        <p:cNvGrpSpPr/>
+        <p:nvPr/>
+      </p:nvGrpSpPr>
+      <p:grpSpPr/>
+      <p:sp>
+        <p:nvSpPr>
+          <p:cNvPr id="2" name="Rectangle 1"/>
           <p:cNvSpPr/>
           <p:nvPr/>
         </p:nvSpPr>
         <p:spPr>
           <a:xfrm>
-            <a:off x="548640" y="3886200"/>
+            <a:off x="548640" y="384048"/>
+            <a:ext cx="822960" cy="82296"/>
+          </a:xfrm>
+          <a:prstGeom prst="rect">
+            <a:avLst/>
+          </a:prstGeom>
+          <a:solidFill>
+            <a:srgbClr val="FFB502"/>
+          </a:solidFill>
+          <a:ln>
+            <a:noFill/>
+          </a:ln>
+          <a:effectLst/>
+        </p:spPr>
+        <p:txBody>
+          <a:bodyPr rtlCol="0" anchor="ctr"/>
+          <a:lstStyle/>
+          <a:p>
+            <a:pPr algn="ctr"/>
+          </a:p>
+        </p:txBody>
+      </p:sp>
+      <p:sp>
+        <p:nvSpPr>
+          <p:cNvPr id="3" name="TextBox 2"/>
+          <p:cNvSpPr txBox="1"/>
+          <p:nvPr/>
+        </p:nvSpPr>
+        <p:spPr>
+          <a:xfrm>
+            <a:off x="548640" y="566928"/>
+            <a:ext cx="11094415" cy="914400"/>
+          </a:xfrm>
+          <a:prstGeom prst="rect">
+            <a:avLst/>
+          </a:prstGeom>
+          <a:noFill/>
+        </p:spPr>
+        <p:txBody>
+          <a:bodyPr wrap="square" lIns="0" rIns="0" tIns="0" bIns="0" anchor="t">
+            <a:spAutoFit/>
+          </a:bodyPr>
+          <a:lstStyle/>
+          <a:p>
+            <a:pPr algn="l">
+              <a:lnSpc>
+                <a:spcPct val="100000"/>
+              </a:lnSpc>
+            </a:pPr>
+            <a:r>
+              <a:rPr sz="2600" b="1">
+                <a:solidFill>
+                  <a:srgbClr val="000000"/>
+                </a:solidFill>
+                <a:latin typeface="Arial"/>
+              </a:rPr>
+              <a:t>What I learned: test the idea first, and trust is built by showing your work</a:t>
+            </a:r>
+          </a:p>
+        </p:txBody>
+      </p:sp>
+      <p:sp>
+        <p:nvSpPr>
+          <p:cNvPr id="4" name="Rectangle 3"/>
+          <p:cNvSpPr/>
+          <p:nvPr/>
+        </p:nvSpPr>
+        <p:spPr>
+          <a:xfrm>
+            <a:off x="548640" y="6291072"/>
             <a:ext cx="11094415" cy="9525"/>
           </a:xfrm>
           <a:prstGeom prst="rect">
@@ -11618,14 +13856,14 @@
       </p:sp>
       <p:sp>
         <p:nvSpPr>
-          <p:cNvPr id="22" name="TextBox 21"/>
+          <p:cNvPr id="5" name="TextBox 4"/>
           <p:cNvSpPr txBox="1"/>
           <p:nvPr/>
         </p:nvSpPr>
         <p:spPr>
           <a:xfrm>
-            <a:off x="548640" y="4069080"/>
-            <a:ext cx="2743200" cy="320040"/>
+            <a:off x="548640" y="6400800"/>
+            <a:ext cx="5486400" cy="274320"/>
           </a:xfrm>
           <a:prstGeom prst="rect">
             <a:avLst/>
@@ -11644,191 +13882,27 @@
               </a:lnSpc>
             </a:pPr>
             <a:r>
-              <a:rPr sz="1400" b="1">
-                <a:solidFill>
-                  <a:srgbClr val="000000"/>
+              <a:rPr sz="1000" b="0">
+                <a:solidFill>
+                  <a:srgbClr val="6E6E6E"/>
                 </a:solidFill>
                 <a:latin typeface="Arial"/>
               </a:rPr>
-              <a:t>Limitations</a:t>
-            </a:r>
-          </a:p>
-        </p:txBody>
-      </p:sp>
-      <p:sp>
-        <p:nvSpPr>
-          <p:cNvPr id="23" name="Rectangle 22"/>
-          <p:cNvSpPr/>
-          <p:nvPr/>
-        </p:nvSpPr>
-        <p:spPr>
-          <a:xfrm>
-            <a:off x="548640" y="4480560"/>
-            <a:ext cx="2567863" cy="685800"/>
-          </a:xfrm>
-          <a:prstGeom prst="rect">
-            <a:avLst/>
-          </a:prstGeom>
-          <a:solidFill>
-            <a:srgbClr val="F2F2F2"/>
-          </a:solidFill>
-          <a:ln w="12700">
-            <a:solidFill>
-              <a:srgbClr val="D9D9D9"/>
-            </a:solidFill>
-          </a:ln>
-          <a:effectLst/>
-        </p:spPr>
-        <p:txBody>
-          <a:bodyPr rtlCol="0" anchor="ctr" lIns="54864" rIns="54864" wrap="square"/>
-          <a:lstStyle/>
-          <a:p>
-            <a:pPr algn="ctr"/>
-            <a:r>
-              <a:rPr sz="1300" b="0">
-                <a:solidFill>
-                  <a:srgbClr val="000000"/>
-                </a:solidFill>
-                <a:latin typeface="Arial"/>
-              </a:rPr>
-              <a:t>Synthetic data so far</a:t>
-            </a:r>
-          </a:p>
-        </p:txBody>
-      </p:sp>
-      <p:sp>
-        <p:nvSpPr>
-          <p:cNvPr id="24" name="Rectangle 23"/>
-          <p:cNvSpPr/>
-          <p:nvPr/>
-        </p:nvSpPr>
-        <p:spPr>
-          <a:xfrm>
-            <a:off x="3390823" y="4480560"/>
-            <a:ext cx="2567863" cy="685800"/>
-          </a:xfrm>
-          <a:prstGeom prst="rect">
-            <a:avLst/>
-          </a:prstGeom>
-          <a:solidFill>
-            <a:srgbClr val="F2F2F2"/>
-          </a:solidFill>
-          <a:ln w="12700">
-            <a:solidFill>
-              <a:srgbClr val="D9D9D9"/>
-            </a:solidFill>
-          </a:ln>
-          <a:effectLst/>
-        </p:spPr>
-        <p:txBody>
-          <a:bodyPr rtlCol="0" anchor="ctr" lIns="54864" rIns="54864" wrap="square"/>
-          <a:lstStyle/>
-          <a:p>
-            <a:pPr algn="ctr"/>
-            <a:r>
-              <a:rPr sz="1300" b="0">
-                <a:solidFill>
-                  <a:srgbClr val="000000"/>
-                </a:solidFill>
-                <a:latin typeface="Arial"/>
-              </a:rPr>
-              <a:t>Plans one replenishment cycle</a:t>
-            </a:r>
-          </a:p>
-        </p:txBody>
-      </p:sp>
-      <p:sp>
-        <p:nvSpPr>
-          <p:cNvPr id="25" name="Rectangle 24"/>
-          <p:cNvSpPr/>
-          <p:nvPr/>
-        </p:nvSpPr>
-        <p:spPr>
-          <a:xfrm>
-            <a:off x="6233006" y="4480560"/>
-            <a:ext cx="2567863" cy="685800"/>
-          </a:xfrm>
-          <a:prstGeom prst="rect">
-            <a:avLst/>
-          </a:prstGeom>
-          <a:solidFill>
-            <a:srgbClr val="F2F2F2"/>
-          </a:solidFill>
-          <a:ln w="12700">
-            <a:solidFill>
-              <a:srgbClr val="D9D9D9"/>
-            </a:solidFill>
-          </a:ln>
-          <a:effectLst/>
-        </p:spPr>
-        <p:txBody>
-          <a:bodyPr rtlCol="0" anchor="ctr" lIns="54864" rIns="54864" wrap="square"/>
-          <a:lstStyle/>
-          <a:p>
-            <a:pPr algn="ctr"/>
-            <a:r>
-              <a:rPr sz="1300" b="0">
-                <a:solidFill>
-                  <a:srgbClr val="000000"/>
-                </a:solidFill>
-                <a:latin typeface="Arial"/>
-              </a:rPr>
-              <a:t>Normal error model for safety stock</a:t>
-            </a:r>
-          </a:p>
-        </p:txBody>
-      </p:sp>
-      <p:sp>
-        <p:nvSpPr>
-          <p:cNvPr id="26" name="Rectangle 25"/>
-          <p:cNvSpPr/>
-          <p:nvPr/>
-        </p:nvSpPr>
-        <p:spPr>
-          <a:xfrm>
-            <a:off x="9075189" y="4480560"/>
-            <a:ext cx="2567863" cy="685800"/>
-          </a:xfrm>
-          <a:prstGeom prst="rect">
-            <a:avLst/>
-          </a:prstGeom>
-          <a:solidFill>
-            <a:srgbClr val="F2F2F2"/>
-          </a:solidFill>
-          <a:ln w="12700">
-            <a:solidFill>
-              <a:srgbClr val="D9D9D9"/>
-            </a:solidFill>
-          </a:ln>
-          <a:effectLst/>
-        </p:spPr>
-        <p:txBody>
-          <a:bodyPr rtlCol="0" anchor="ctr" lIns="54864" rIns="54864" wrap="square"/>
-          <a:lstStyle/>
-          <a:p>
-            <a:pPr algn="ctr"/>
-            <a:r>
-              <a:rPr sz="1300" b="0">
-                <a:solidFill>
-                  <a:srgbClr val="000000"/>
-                </a:solidFill>
-                <a:latin typeface="Arial"/>
-              </a:rPr>
-              <a:t>Costs need finance approval</a:t>
-            </a:r>
-          </a:p>
-        </p:txBody>
-      </p:sp>
-      <p:sp>
-        <p:nvSpPr>
-          <p:cNvPr id="27" name="TextBox 26"/>
+              <a:t>Synthetic data – for demonstration</a:t>
+            </a:r>
+          </a:p>
+        </p:txBody>
+      </p:sp>
+      <p:sp>
+        <p:nvSpPr>
+          <p:cNvPr id="6" name="TextBox 5"/>
           <p:cNvSpPr txBox="1"/>
           <p:nvPr/>
         </p:nvSpPr>
         <p:spPr>
           <a:xfrm>
-            <a:off x="548640" y="5486400"/>
-            <a:ext cx="11094415" cy="548640"/>
+            <a:off x="10728655" y="6400800"/>
+            <a:ext cx="914400" cy="274320"/>
           </a:xfrm>
           <a:prstGeom prst="rect">
             <a:avLst/>
@@ -11841,19 +13915,571 @@
           </a:bodyPr>
           <a:lstStyle/>
           <a:p>
-            <a:pPr algn="ctr">
+            <a:pPr algn="r">
               <a:lnSpc>
                 <a:spcPct val="110000"/>
               </a:lnSpc>
             </a:pPr>
             <a:r>
-              <a:rPr sz="1600" b="1">
-                <a:solidFill>
-                  <a:srgbClr val="000000"/>
+              <a:rPr sz="1000" b="0">
+                <a:solidFill>
+                  <a:srgbClr val="6E6E6E"/>
                 </a:solidFill>
                 <a:latin typeface="Arial"/>
               </a:rPr>
-              <a:t>Right product, right branch: surgeons don't wait, so patients don't either.</a:t>
+              <a:t>9</a:t>
+            </a:r>
+          </a:p>
+        </p:txBody>
+      </p:sp>
+      <p:sp>
+        <p:nvSpPr>
+          <p:cNvPr id="7" name="Rectangle 6"/>
+          <p:cNvSpPr/>
+          <p:nvPr/>
+        </p:nvSpPr>
+        <p:spPr>
+          <a:xfrm>
+            <a:off x="548640" y="1645920"/>
+            <a:ext cx="5364327" cy="2080260"/>
+          </a:xfrm>
+          <a:prstGeom prst="rect">
+            <a:avLst/>
+          </a:prstGeom>
+          <a:solidFill>
+            <a:srgbClr val="F2F2F2"/>
+          </a:solidFill>
+          <a:ln>
+            <a:noFill/>
+          </a:ln>
+          <a:effectLst/>
+        </p:spPr>
+        <p:txBody>
+          <a:bodyPr rtlCol="0" anchor="ctr"/>
+          <a:lstStyle/>
+          <a:p>
+            <a:pPr algn="ctr"/>
+          </a:p>
+        </p:txBody>
+      </p:sp>
+      <p:sp>
+        <p:nvSpPr>
+          <p:cNvPr id="8" name="Rectangle 7"/>
+          <p:cNvSpPr/>
+          <p:nvPr/>
+        </p:nvSpPr>
+        <p:spPr>
+          <a:xfrm>
+            <a:off x="548640" y="1645920"/>
+            <a:ext cx="82296" cy="2080260"/>
+          </a:xfrm>
+          <a:prstGeom prst="rect">
+            <a:avLst/>
+          </a:prstGeom>
+          <a:solidFill>
+            <a:srgbClr val="FFB502"/>
+          </a:solidFill>
+          <a:ln>
+            <a:noFill/>
+          </a:ln>
+          <a:effectLst/>
+        </p:spPr>
+        <p:txBody>
+          <a:bodyPr rtlCol="0" anchor="ctr"/>
+          <a:lstStyle/>
+          <a:p>
+            <a:pPr algn="ctr"/>
+          </a:p>
+        </p:txBody>
+      </p:sp>
+      <p:sp>
+        <p:nvSpPr>
+          <p:cNvPr id="9" name="TextBox 8"/>
+          <p:cNvSpPr txBox="1"/>
+          <p:nvPr/>
+        </p:nvSpPr>
+        <p:spPr>
+          <a:xfrm>
+            <a:off x="822960" y="1828800"/>
+            <a:ext cx="4861407" cy="457200"/>
+          </a:xfrm>
+          <a:prstGeom prst="rect">
+            <a:avLst/>
+          </a:prstGeom>
+          <a:noFill/>
+        </p:spPr>
+        <p:txBody>
+          <a:bodyPr wrap="square" lIns="0" rIns="0" tIns="0" bIns="0" anchor="t">
+            <a:spAutoFit/>
+          </a:bodyPr>
+          <a:lstStyle/>
+          <a:p>
+            <a:pPr algn="l">
+              <a:lnSpc>
+                <a:spcPct val="110000"/>
+              </a:lnSpc>
+            </a:pPr>
+            <a:r>
+              <a:rPr sz="1900" b="1">
+                <a:solidFill>
+                  <a:srgbClr val="000000"/>
+                </a:solidFill>
+                <a:latin typeface="Arial"/>
+              </a:rPr>
+              <a:t>Test the hypothesis before the fix</a:t>
+            </a:r>
+          </a:p>
+        </p:txBody>
+      </p:sp>
+      <p:sp>
+        <p:nvSpPr>
+          <p:cNvPr id="10" name="TextBox 9"/>
+          <p:cNvSpPr txBox="1"/>
+          <p:nvPr/>
+        </p:nvSpPr>
+        <p:spPr>
+          <a:xfrm>
+            <a:off x="822960" y="2377440"/>
+            <a:ext cx="4861407" cy="1211580"/>
+          </a:xfrm>
+          <a:prstGeom prst="rect">
+            <a:avLst/>
+          </a:prstGeom>
+          <a:noFill/>
+        </p:spPr>
+        <p:txBody>
+          <a:bodyPr wrap="square" lIns="0" rIns="0" tIns="0" bIns="0" anchor="t">
+            <a:spAutoFit/>
+          </a:bodyPr>
+          <a:lstStyle/>
+          <a:p>
+            <a:pPr algn="l">
+              <a:lnSpc>
+                <a:spcPct val="120000"/>
+              </a:lnSpc>
+            </a:pPr>
+            <a:r>
+              <a:rPr sz="1500" b="0">
+                <a:solidFill>
+                  <a:srgbClr val="333333"/>
+                </a:solidFill>
+                <a:latin typeface="Arial"/>
+              </a:rPr>
+              <a:t>My first theory for the bias was wrong. A quick experiment saved days of fixing the wrong thing.</a:t>
+            </a:r>
+          </a:p>
+        </p:txBody>
+      </p:sp>
+      <p:sp>
+        <p:nvSpPr>
+          <p:cNvPr id="11" name="Rectangle 10"/>
+          <p:cNvSpPr/>
+          <p:nvPr/>
+        </p:nvSpPr>
+        <p:spPr>
+          <a:xfrm>
+            <a:off x="6278727" y="1645920"/>
+            <a:ext cx="5364327" cy="2080260"/>
+          </a:xfrm>
+          <a:prstGeom prst="rect">
+            <a:avLst/>
+          </a:prstGeom>
+          <a:solidFill>
+            <a:srgbClr val="F2F2F2"/>
+          </a:solidFill>
+          <a:ln>
+            <a:noFill/>
+          </a:ln>
+          <a:effectLst/>
+        </p:spPr>
+        <p:txBody>
+          <a:bodyPr rtlCol="0" anchor="ctr"/>
+          <a:lstStyle/>
+          <a:p>
+            <a:pPr algn="ctr"/>
+          </a:p>
+        </p:txBody>
+      </p:sp>
+      <p:sp>
+        <p:nvSpPr>
+          <p:cNvPr id="12" name="Rectangle 11"/>
+          <p:cNvSpPr/>
+          <p:nvPr/>
+        </p:nvSpPr>
+        <p:spPr>
+          <a:xfrm>
+            <a:off x="6278727" y="1645920"/>
+            <a:ext cx="82296" cy="2080260"/>
+          </a:xfrm>
+          <a:prstGeom prst="rect">
+            <a:avLst/>
+          </a:prstGeom>
+          <a:solidFill>
+            <a:srgbClr val="333333"/>
+          </a:solidFill>
+          <a:ln>
+            <a:noFill/>
+          </a:ln>
+          <a:effectLst/>
+        </p:spPr>
+        <p:txBody>
+          <a:bodyPr rtlCol="0" anchor="ctr"/>
+          <a:lstStyle/>
+          <a:p>
+            <a:pPr algn="ctr"/>
+          </a:p>
+        </p:txBody>
+      </p:sp>
+      <p:sp>
+        <p:nvSpPr>
+          <p:cNvPr id="13" name="TextBox 12"/>
+          <p:cNvSpPr txBox="1"/>
+          <p:nvPr/>
+        </p:nvSpPr>
+        <p:spPr>
+          <a:xfrm>
+            <a:off x="6553047" y="1828800"/>
+            <a:ext cx="4861407" cy="457200"/>
+          </a:xfrm>
+          <a:prstGeom prst="rect">
+            <a:avLst/>
+          </a:prstGeom>
+          <a:noFill/>
+        </p:spPr>
+        <p:txBody>
+          <a:bodyPr wrap="square" lIns="0" rIns="0" tIns="0" bIns="0" anchor="t">
+            <a:spAutoFit/>
+          </a:bodyPr>
+          <a:lstStyle/>
+          <a:p>
+            <a:pPr algn="l">
+              <a:lnSpc>
+                <a:spcPct val="110000"/>
+              </a:lnSpc>
+            </a:pPr>
+            <a:r>
+              <a:rPr sz="1900" b="1">
+                <a:solidFill>
+                  <a:srgbClr val="000000"/>
+                </a:solidFill>
+                <a:latin typeface="Arial"/>
+              </a:rPr>
+              <a:t>Beat the baseline; say where you don't</a:t>
+            </a:r>
+          </a:p>
+        </p:txBody>
+      </p:sp>
+      <p:sp>
+        <p:nvSpPr>
+          <p:cNvPr id="14" name="TextBox 13"/>
+          <p:cNvSpPr txBox="1"/>
+          <p:nvPr/>
+        </p:nvSpPr>
+        <p:spPr>
+          <a:xfrm>
+            <a:off x="6553047" y="2377440"/>
+            <a:ext cx="4861407" cy="1211580"/>
+          </a:xfrm>
+          <a:prstGeom prst="rect">
+            <a:avLst/>
+          </a:prstGeom>
+          <a:noFill/>
+        </p:spPr>
+        <p:txBody>
+          <a:bodyPr wrap="square" lIns="0" rIns="0" tIns="0" bIns="0" anchor="t">
+            <a:spAutoFit/>
+          </a:bodyPr>
+          <a:lstStyle/>
+          <a:p>
+            <a:pPr algn="l">
+              <a:lnSpc>
+                <a:spcPct val="120000"/>
+              </a:lnSpc>
+            </a:pPr>
+            <a:r>
+              <a:rPr sz="1500" b="0">
+                <a:solidFill>
+                  <a:srgbClr val="333333"/>
+                </a:solidFill>
+                <a:latin typeface="Arial"/>
+              </a:rPr>
+              <a:t>The model still loses on 19% of series, mostly slow movers. Showing it made the rest more credible.</a:t>
+            </a:r>
+          </a:p>
+        </p:txBody>
+      </p:sp>
+      <p:sp>
+        <p:nvSpPr>
+          <p:cNvPr id="15" name="Rectangle 14"/>
+          <p:cNvSpPr/>
+          <p:nvPr/>
+        </p:nvSpPr>
+        <p:spPr>
+          <a:xfrm>
+            <a:off x="548640" y="4000500"/>
+            <a:ext cx="5364327" cy="2080260"/>
+          </a:xfrm>
+          <a:prstGeom prst="rect">
+            <a:avLst/>
+          </a:prstGeom>
+          <a:solidFill>
+            <a:srgbClr val="F2F2F2"/>
+          </a:solidFill>
+          <a:ln>
+            <a:noFill/>
+          </a:ln>
+          <a:effectLst/>
+        </p:spPr>
+        <p:txBody>
+          <a:bodyPr rtlCol="0" anchor="ctr"/>
+          <a:lstStyle/>
+          <a:p>
+            <a:pPr algn="ctr"/>
+          </a:p>
+        </p:txBody>
+      </p:sp>
+      <p:sp>
+        <p:nvSpPr>
+          <p:cNvPr id="16" name="Rectangle 15"/>
+          <p:cNvSpPr/>
+          <p:nvPr/>
+        </p:nvSpPr>
+        <p:spPr>
+          <a:xfrm>
+            <a:off x="548640" y="4000500"/>
+            <a:ext cx="82296" cy="2080260"/>
+          </a:xfrm>
+          <a:prstGeom prst="rect">
+            <a:avLst/>
+          </a:prstGeom>
+          <a:solidFill>
+            <a:srgbClr val="333333"/>
+          </a:solidFill>
+          <a:ln>
+            <a:noFill/>
+          </a:ln>
+          <a:effectLst/>
+        </p:spPr>
+        <p:txBody>
+          <a:bodyPr rtlCol="0" anchor="ctr"/>
+          <a:lstStyle/>
+          <a:p>
+            <a:pPr algn="ctr"/>
+          </a:p>
+        </p:txBody>
+      </p:sp>
+      <p:sp>
+        <p:nvSpPr>
+          <p:cNvPr id="17" name="TextBox 16"/>
+          <p:cNvSpPr txBox="1"/>
+          <p:nvPr/>
+        </p:nvSpPr>
+        <p:spPr>
+          <a:xfrm>
+            <a:off x="822960" y="4183380"/>
+            <a:ext cx="4861407" cy="457200"/>
+          </a:xfrm>
+          <a:prstGeom prst="rect">
+            <a:avLst/>
+          </a:prstGeom>
+          <a:noFill/>
+        </p:spPr>
+        <p:txBody>
+          <a:bodyPr wrap="square" lIns="0" rIns="0" tIns="0" bIns="0" anchor="t">
+            <a:spAutoFit/>
+          </a:bodyPr>
+          <a:lstStyle/>
+          <a:p>
+            <a:pPr algn="l">
+              <a:lnSpc>
+                <a:spcPct val="110000"/>
+              </a:lnSpc>
+            </a:pPr>
+            <a:r>
+              <a:rPr sz="1900" b="1">
+                <a:solidFill>
+                  <a:srgbClr val="000000"/>
+                </a:solidFill>
+                <a:latin typeface="Arial"/>
+              </a:rPr>
+              <a:t>Explainability drives adoption</a:t>
+            </a:r>
+          </a:p>
+        </p:txBody>
+      </p:sp>
+      <p:sp>
+        <p:nvSpPr>
+          <p:cNvPr id="18" name="TextBox 17"/>
+          <p:cNvSpPr txBox="1"/>
+          <p:nvPr/>
+        </p:nvSpPr>
+        <p:spPr>
+          <a:xfrm>
+            <a:off x="822960" y="4732020"/>
+            <a:ext cx="4861407" cy="1211580"/>
+          </a:xfrm>
+          <a:prstGeom prst="rect">
+            <a:avLst/>
+          </a:prstGeom>
+          <a:noFill/>
+        </p:spPr>
+        <p:txBody>
+          <a:bodyPr wrap="square" lIns="0" rIns="0" tIns="0" bIns="0" anchor="t">
+            <a:spAutoFit/>
+          </a:bodyPr>
+          <a:lstStyle/>
+          <a:p>
+            <a:pPr algn="l">
+              <a:lnSpc>
+                <a:spcPct val="120000"/>
+              </a:lnSpc>
+            </a:pPr>
+            <a:r>
+              <a:rPr sz="1500" b="0">
+                <a:solidFill>
+                  <a:srgbClr val="333333"/>
+                </a:solidFill>
+                <a:latin typeface="Arial"/>
+              </a:rPr>
+              <a:t>A reason a branch manager can check is worth more than one more point of accuracy.</a:t>
+            </a:r>
+          </a:p>
+        </p:txBody>
+      </p:sp>
+      <p:sp>
+        <p:nvSpPr>
+          <p:cNvPr id="19" name="Rectangle 18"/>
+          <p:cNvSpPr/>
+          <p:nvPr/>
+        </p:nvSpPr>
+        <p:spPr>
+          <a:xfrm>
+            <a:off x="6278727" y="4000500"/>
+            <a:ext cx="5364327" cy="2080260"/>
+          </a:xfrm>
+          <a:prstGeom prst="rect">
+            <a:avLst/>
+          </a:prstGeom>
+          <a:solidFill>
+            <a:srgbClr val="F2F2F2"/>
+          </a:solidFill>
+          <a:ln>
+            <a:noFill/>
+          </a:ln>
+          <a:effectLst/>
+        </p:spPr>
+        <p:txBody>
+          <a:bodyPr rtlCol="0" anchor="ctr"/>
+          <a:lstStyle/>
+          <a:p>
+            <a:pPr algn="ctr"/>
+          </a:p>
+        </p:txBody>
+      </p:sp>
+      <p:sp>
+        <p:nvSpPr>
+          <p:cNvPr id="20" name="Rectangle 19"/>
+          <p:cNvSpPr/>
+          <p:nvPr/>
+        </p:nvSpPr>
+        <p:spPr>
+          <a:xfrm>
+            <a:off x="6278727" y="4000500"/>
+            <a:ext cx="82296" cy="2080260"/>
+          </a:xfrm>
+          <a:prstGeom prst="rect">
+            <a:avLst/>
+          </a:prstGeom>
+          <a:solidFill>
+            <a:srgbClr val="FFB502"/>
+          </a:solidFill>
+          <a:ln>
+            <a:noFill/>
+          </a:ln>
+          <a:effectLst/>
+        </p:spPr>
+        <p:txBody>
+          <a:bodyPr rtlCol="0" anchor="ctr"/>
+          <a:lstStyle/>
+          <a:p>
+            <a:pPr algn="ctr"/>
+          </a:p>
+        </p:txBody>
+      </p:sp>
+      <p:sp>
+        <p:nvSpPr>
+          <p:cNvPr id="21" name="TextBox 20"/>
+          <p:cNvSpPr txBox="1"/>
+          <p:nvPr/>
+        </p:nvSpPr>
+        <p:spPr>
+          <a:xfrm>
+            <a:off x="6553047" y="4183380"/>
+            <a:ext cx="4861407" cy="457200"/>
+          </a:xfrm>
+          <a:prstGeom prst="rect">
+            <a:avLst/>
+          </a:prstGeom>
+          <a:noFill/>
+        </p:spPr>
+        <p:txBody>
+          <a:bodyPr wrap="square" lIns="0" rIns="0" tIns="0" bIns="0" anchor="t">
+            <a:spAutoFit/>
+          </a:bodyPr>
+          <a:lstStyle/>
+          <a:p>
+            <a:pPr algn="l">
+              <a:lnSpc>
+                <a:spcPct val="110000"/>
+              </a:lnSpc>
+            </a:pPr>
+            <a:r>
+              <a:rPr sz="1900" b="1">
+                <a:solidFill>
+                  <a:srgbClr val="000000"/>
+                </a:solidFill>
+                <a:latin typeface="Arial"/>
+              </a:rPr>
+              <a:t>Delete work that doesn't earn its place</a:t>
+            </a:r>
+          </a:p>
+        </p:txBody>
+      </p:sp>
+      <p:sp>
+        <p:nvSpPr>
+          <p:cNvPr id="22" name="TextBox 21"/>
+          <p:cNvSpPr txBox="1"/>
+          <p:nvPr/>
+        </p:nvSpPr>
+        <p:spPr>
+          <a:xfrm>
+            <a:off x="6553047" y="4732020"/>
+            <a:ext cx="4861407" cy="1211580"/>
+          </a:xfrm>
+          <a:prstGeom prst="rect">
+            <a:avLst/>
+          </a:prstGeom>
+          <a:noFill/>
+        </p:spPr>
+        <p:txBody>
+          <a:bodyPr wrap="square" lIns="0" rIns="0" tIns="0" bIns="0" anchor="t">
+            <a:spAutoFit/>
+          </a:bodyPr>
+          <a:lstStyle/>
+          <a:p>
+            <a:pPr algn="l">
+              <a:lnSpc>
+                <a:spcPct val="120000"/>
+              </a:lnSpc>
+            </a:pPr>
+            <a:r>
+              <a:rPr sz="1500" b="0">
+                <a:solidFill>
+                  <a:srgbClr val="333333"/>
+                </a:solidFill>
+                <a:latin typeface="Arial"/>
+              </a:rPr>
+              <a:t>A branch-level correction added noise without helping, so I removed it.</a:t>
             </a:r>
           </a:p>
         </p:txBody>

</xml_diff>